<commit_message>
Update presentation text for exact TSP and OSRM routing
</commit_message>
<xml_diff>
--- a/Flikart_Grid_Lock_hackathon_Round_2_Confluent.pptx
+++ b/Flikart_Grid_Lock_hackathon_Round_2_Confluent.pptx
@@ -3690,7 +3690,7 @@
             </a:pPr>
             <a:r>
               <a:rPr lang="en-US" sz="1400" dirty="0"/>
-              <a:t>      - Warden navigation app. Deploy towing fleet size matching.</a:t>
+              <a:t>      - Live turn-by-turn mobile app sync. Deploy towing fleet size matching.</a:t>
             </a:r>
           </a:p>
           <a:p>
@@ -5831,7 +5831,7 @@
             </a:r>
             <a:r>
               <a:rPr sz="1600" dirty="0"/>
-              <a:t>Generates optimized nearest-neighbor officer routing paths on the map in &lt;1ms.</a:t>
+              <a:t>Generates exact TSP shortest tours snapped to road networks in &lt;1ms.</a:t>
             </a:r>
           </a:p>
           <a:p>
@@ -7299,7 +7299,7 @@
             </a:r>
             <a:r>
               <a:rPr sz="1600" dirty="0"/>
-              <a:t>Greedy Pathfinder Dispatch</a:t>
+              <a:t>Exact TSP &amp; Road-Snapping Dispatch</a:t>
             </a:r>
             <a:r>
               <a:rPr lang="en-US" sz="1600" dirty="0"/>
@@ -7324,7 +7324,7 @@
             </a:r>
             <a:r>
               <a:rPr sz="1600" dirty="0"/>
-              <a:t>- Executes nearest-neighbor routing algorithms in </a:t>
+              <a:t>- Solves Exact TSP tour in &lt;1ms and snaps routes to roads using OSRM for wardens.</a:t>
             </a:r>
             <a:r>
               <a:rPr lang="en-US" sz="1600" dirty="0"/>
@@ -7332,7 +7332,7 @@
             </a:r>
             <a:r>
               <a:rPr sz="1600" dirty="0"/>
-              <a:t>&lt;1ms to dispatch wardens.</a:t>
+              <a:t/>
             </a:r>
           </a:p>
         </p:txBody>
@@ -8350,7 +8350,7 @@
             </a:r>
             <a:r>
               <a:rPr sz="1300" b="1" u="sng" dirty="0"/>
-              <a:t>Greedy Nearest-Neighbor Pathfinder routing:</a:t>
+              <a:t>Exact TSP Shortest Tour Pathfinder (OSRM Road-Snapping):</a:t>
             </a:r>
           </a:p>
           <a:p>
@@ -8375,11 +8375,11 @@
             </a:r>
             <a:r>
               <a:rPr lang="en-US" sz="1300" dirty="0"/>
-              <a:t>S</a:t>
+              <a:t/>
             </a:r>
             <a:r>
               <a:rPr sz="1300" dirty="0"/>
-              <a:t>tarts at max congestion, sequentially pathing to nearest hotspot.</a:t>
+              <a:t>Solves Traveling Salesperson Problem (TSP) exactly to find the absolute shortest round tour.</a:t>
             </a:r>
           </a:p>
           <a:p>
@@ -8400,7 +8400,7 @@
             </a:r>
             <a:r>
               <a:rPr sz="1300" dirty="0"/>
-              <a:t>- O(N^2) complexity with local path planning executed in &lt;1ms.</a:t>
+              <a:t>- Snaps path to live road geometry via OSRM, including real turn-by-turn navigation.</a:t>
             </a:r>
           </a:p>
           <a:p>
@@ -9466,7 +9466,7 @@
               </a:defRPr>
             </a:pPr>
             <a:r>
-              <a:t>Pathfinder maps optimal routes sequentially in &lt;1ms.</a:t>
+              <a:t>Pathfinder calculates exact TSP route snapped to road network in &lt;1ms.</a:t>
             </a:r>
           </a:p>
         </p:txBody>
@@ -9524,7 +9524,7 @@
               </a:defRPr>
             </a:pPr>
             <a:r>
-              <a:t>Officers navigate drawn polylines to clear blockages.</a:t>
+              <a:t>Warden gets real-time GPS turn-by-turn navigation in the dashboard.</a:t>
             </a:r>
           </a:p>
         </p:txBody>

</xml_diff>

<commit_message>
Regenerate source code zip and update presentation on GitHub
</commit_message>
<xml_diff>
--- a/Flikart_Grid_Lock_hackathon_Round_2_Confluent.pptx
+++ b/Flikart_Grid_Lock_hackathon_Round_2_Confluent.pptx
@@ -4,6 +4,9 @@
   <p:sldMasterIdLst>
     <p:sldMasterId id="2147483648" r:id="rId1"/>
   </p:sldMasterIdLst>
+  <p:notesMasterIdLst>
+    <p:notesMasterId r:id="rId14"/>
+  </p:notesMasterIdLst>
   <p:sldIdLst>
     <p:sldId id="256" r:id="rId2"/>
     <p:sldId id="265" r:id="rId3"/>
@@ -134,6 +137,439 @@
 </p:presentation>
 </file>
 
+<file path=ppt/notesMasters/notesMaster1.xml><?xml version="1.0" encoding="utf-8"?>
+<p:notesMaster xmlns:a="http://schemas.openxmlformats.org/drawingml/2006/main" xmlns:r="http://schemas.openxmlformats.org/officeDocument/2006/relationships" xmlns:p="http://schemas.openxmlformats.org/presentationml/2006/main">
+  <p:cSld>
+    <p:bg>
+      <p:bgRef idx="1001">
+        <a:schemeClr val="bg1"/>
+      </p:bgRef>
+    </p:bg>
+    <p:spTree>
+      <p:nvGrpSpPr>
+        <p:cNvPr id="1" name=""/>
+        <p:cNvGrpSpPr/>
+        <p:nvPr/>
+      </p:nvGrpSpPr>
+      <p:grpSpPr>
+        <a:xfrm>
+          <a:off x="0" y="0"/>
+          <a:ext cx="0" cy="0"/>
+          <a:chOff x="0" y="0"/>
+          <a:chExt cx="0" cy="0"/>
+        </a:xfrm>
+      </p:grpSpPr>
+      <p:sp>
+        <p:nvSpPr>
+          <p:cNvPr id="2" name="Header Placeholder 1"/>
+          <p:cNvSpPr>
+            <a:spLocks noGrp="1"/>
+          </p:cNvSpPr>
+          <p:nvPr>
+            <p:ph type="hdr" sz="quarter"/>
+          </p:nvPr>
+        </p:nvSpPr>
+        <p:spPr>
+          <a:xfrm>
+            <a:off x="0" y="0"/>
+            <a:ext cx="2971800" cy="458788"/>
+          </a:xfrm>
+          <a:prstGeom prst="rect">
+            <a:avLst/>
+          </a:prstGeom>
+        </p:spPr>
+        <p:txBody>
+          <a:bodyPr vert="horz" lIns="91440" tIns="45720" rIns="91440" bIns="45720" rtlCol="0"/>
+          <a:lstStyle>
+            <a:lvl1pPr algn="l">
+              <a:defRPr sz="1200"/>
+            </a:lvl1pPr>
+          </a:lstStyle>
+          <a:p>
+            <a:endParaRPr lang="en-US"/>
+          </a:p>
+        </p:txBody>
+      </p:sp>
+      <p:sp>
+        <p:nvSpPr>
+          <p:cNvPr id="3" name="Date Placeholder 2"/>
+          <p:cNvSpPr>
+            <a:spLocks noGrp="1"/>
+          </p:cNvSpPr>
+          <p:nvPr>
+            <p:ph type="dt" idx="1"/>
+          </p:nvPr>
+        </p:nvSpPr>
+        <p:spPr>
+          <a:xfrm>
+            <a:off x="3884613" y="0"/>
+            <a:ext cx="2971800" cy="458788"/>
+          </a:xfrm>
+          <a:prstGeom prst="rect">
+            <a:avLst/>
+          </a:prstGeom>
+        </p:spPr>
+        <p:txBody>
+          <a:bodyPr vert="horz" lIns="91440" tIns="45720" rIns="91440" bIns="45720" rtlCol="0"/>
+          <a:lstStyle>
+            <a:lvl1pPr algn="r">
+              <a:defRPr sz="1200"/>
+            </a:lvl1pPr>
+          </a:lstStyle>
+          <a:p>
+            <a:fld id="{5C8CBD25-6209-B341-A3EB-3CFC2FF39C7A}" type="datetimeFigureOut">
+              <a:rPr lang="en-US" smtClean="0"/>
+              <a:t>6/22/26</a:t>
+            </a:fld>
+            <a:endParaRPr lang="en-US"/>
+          </a:p>
+        </p:txBody>
+      </p:sp>
+      <p:sp>
+        <p:nvSpPr>
+          <p:cNvPr id="4" name="Slide Image Placeholder 3"/>
+          <p:cNvSpPr>
+            <a:spLocks noGrp="1" noRot="1" noChangeAspect="1"/>
+          </p:cNvSpPr>
+          <p:nvPr>
+            <p:ph type="sldImg" idx="2"/>
+          </p:nvPr>
+        </p:nvSpPr>
+        <p:spPr>
+          <a:xfrm>
+            <a:off x="685800" y="1143000"/>
+            <a:ext cx="5486400" cy="3086100"/>
+          </a:xfrm>
+          <a:prstGeom prst="rect">
+            <a:avLst/>
+          </a:prstGeom>
+          <a:noFill/>
+          <a:ln w="12700">
+            <a:solidFill>
+              <a:prstClr val="black"/>
+            </a:solidFill>
+          </a:ln>
+        </p:spPr>
+        <p:txBody>
+          <a:bodyPr vert="horz" lIns="91440" tIns="45720" rIns="91440" bIns="45720" rtlCol="0" anchor="ctr"/>
+          <a:lstStyle/>
+          <a:p>
+            <a:endParaRPr lang="en-US"/>
+          </a:p>
+        </p:txBody>
+      </p:sp>
+      <p:sp>
+        <p:nvSpPr>
+          <p:cNvPr id="5" name="Notes Placeholder 4"/>
+          <p:cNvSpPr>
+            <a:spLocks noGrp="1"/>
+          </p:cNvSpPr>
+          <p:nvPr>
+            <p:ph type="body" sz="quarter" idx="3"/>
+          </p:nvPr>
+        </p:nvSpPr>
+        <p:spPr>
+          <a:xfrm>
+            <a:off x="685800" y="4400550"/>
+            <a:ext cx="5486400" cy="3600450"/>
+          </a:xfrm>
+          <a:prstGeom prst="rect">
+            <a:avLst/>
+          </a:prstGeom>
+        </p:spPr>
+        <p:txBody>
+          <a:bodyPr vert="horz" lIns="91440" tIns="45720" rIns="91440" bIns="45720" rtlCol="0"/>
+          <a:lstStyle/>
+          <a:p>
+            <a:pPr lvl="0"/>
+            <a:r>
+              <a:rPr lang="en-US"/>
+              <a:t>Edit Master text styles</a:t>
+            </a:r>
+          </a:p>
+          <a:p>
+            <a:pPr lvl="1"/>
+            <a:r>
+              <a:rPr lang="en-US"/>
+              <a:t>Second level</a:t>
+            </a:r>
+          </a:p>
+          <a:p>
+            <a:pPr lvl="2"/>
+            <a:r>
+              <a:rPr lang="en-US"/>
+              <a:t>Third level</a:t>
+            </a:r>
+          </a:p>
+          <a:p>
+            <a:pPr lvl="3"/>
+            <a:r>
+              <a:rPr lang="en-US"/>
+              <a:t>Fourth level</a:t>
+            </a:r>
+          </a:p>
+          <a:p>
+            <a:pPr lvl="4"/>
+            <a:r>
+              <a:rPr lang="en-US"/>
+              <a:t>Fifth level</a:t>
+            </a:r>
+          </a:p>
+        </p:txBody>
+      </p:sp>
+      <p:sp>
+        <p:nvSpPr>
+          <p:cNvPr id="6" name="Footer Placeholder 5"/>
+          <p:cNvSpPr>
+            <a:spLocks noGrp="1"/>
+          </p:cNvSpPr>
+          <p:nvPr>
+            <p:ph type="ftr" sz="quarter" idx="4"/>
+          </p:nvPr>
+        </p:nvSpPr>
+        <p:spPr>
+          <a:xfrm>
+            <a:off x="0" y="8685213"/>
+            <a:ext cx="2971800" cy="458787"/>
+          </a:xfrm>
+          <a:prstGeom prst="rect">
+            <a:avLst/>
+          </a:prstGeom>
+        </p:spPr>
+        <p:txBody>
+          <a:bodyPr vert="horz" lIns="91440" tIns="45720" rIns="91440" bIns="45720" rtlCol="0" anchor="b"/>
+          <a:lstStyle>
+            <a:lvl1pPr algn="l">
+              <a:defRPr sz="1200"/>
+            </a:lvl1pPr>
+          </a:lstStyle>
+          <a:p>
+            <a:endParaRPr lang="en-US"/>
+          </a:p>
+        </p:txBody>
+      </p:sp>
+      <p:sp>
+        <p:nvSpPr>
+          <p:cNvPr id="7" name="Slide Number Placeholder 6"/>
+          <p:cNvSpPr>
+            <a:spLocks noGrp="1"/>
+          </p:cNvSpPr>
+          <p:nvPr>
+            <p:ph type="sldNum" sz="quarter" idx="5"/>
+          </p:nvPr>
+        </p:nvSpPr>
+        <p:spPr>
+          <a:xfrm>
+            <a:off x="3884613" y="8685213"/>
+            <a:ext cx="2971800" cy="458787"/>
+          </a:xfrm>
+          <a:prstGeom prst="rect">
+            <a:avLst/>
+          </a:prstGeom>
+        </p:spPr>
+        <p:txBody>
+          <a:bodyPr vert="horz" lIns="91440" tIns="45720" rIns="91440" bIns="45720" rtlCol="0" anchor="b"/>
+          <a:lstStyle>
+            <a:lvl1pPr algn="r">
+              <a:defRPr sz="1200"/>
+            </a:lvl1pPr>
+          </a:lstStyle>
+          <a:p>
+            <a:fld id="{8697A498-47AA-1043-BA67-9567D7B7BA32}" type="slidenum">
+              <a:rPr lang="en-US" smtClean="0"/>
+              <a:t>‹#›</a:t>
+            </a:fld>
+            <a:endParaRPr lang="en-US"/>
+          </a:p>
+        </p:txBody>
+      </p:sp>
+    </p:spTree>
+    <p:extLst>
+      <p:ext uri="{BB962C8B-B14F-4D97-AF65-F5344CB8AC3E}">
+        <p14:creationId xmlns:p14="http://schemas.microsoft.com/office/powerpoint/2010/main" val="1299757266"/>
+      </p:ext>
+    </p:extLst>
+  </p:cSld>
+  <p:clrMap bg1="lt1" tx1="dk1" bg2="lt2" tx2="dk2" accent1="accent1" accent2="accent2" accent3="accent3" accent4="accent4" accent5="accent5" accent6="accent6" hlink="hlink" folHlink="folHlink"/>
+  <p:notesStyle>
+    <a:lvl1pPr marL="0" algn="l" defTabSz="914400" rtl="0" eaLnBrk="1" latinLnBrk="0" hangingPunct="1">
+      <a:defRPr sz="1200" kern="1200">
+        <a:solidFill>
+          <a:schemeClr val="tx1"/>
+        </a:solidFill>
+        <a:latin typeface="+mn-lt"/>
+        <a:ea typeface="+mn-ea"/>
+        <a:cs typeface="+mn-cs"/>
+      </a:defRPr>
+    </a:lvl1pPr>
+    <a:lvl2pPr marL="457200" algn="l" defTabSz="914400" rtl="0" eaLnBrk="1" latinLnBrk="0" hangingPunct="1">
+      <a:defRPr sz="1200" kern="1200">
+        <a:solidFill>
+          <a:schemeClr val="tx1"/>
+        </a:solidFill>
+        <a:latin typeface="+mn-lt"/>
+        <a:ea typeface="+mn-ea"/>
+        <a:cs typeface="+mn-cs"/>
+      </a:defRPr>
+    </a:lvl2pPr>
+    <a:lvl3pPr marL="914400" algn="l" defTabSz="914400" rtl="0" eaLnBrk="1" latinLnBrk="0" hangingPunct="1">
+      <a:defRPr sz="1200" kern="1200">
+        <a:solidFill>
+          <a:schemeClr val="tx1"/>
+        </a:solidFill>
+        <a:latin typeface="+mn-lt"/>
+        <a:ea typeface="+mn-ea"/>
+        <a:cs typeface="+mn-cs"/>
+      </a:defRPr>
+    </a:lvl3pPr>
+    <a:lvl4pPr marL="1371600" algn="l" defTabSz="914400" rtl="0" eaLnBrk="1" latinLnBrk="0" hangingPunct="1">
+      <a:defRPr sz="1200" kern="1200">
+        <a:solidFill>
+          <a:schemeClr val="tx1"/>
+        </a:solidFill>
+        <a:latin typeface="+mn-lt"/>
+        <a:ea typeface="+mn-ea"/>
+        <a:cs typeface="+mn-cs"/>
+      </a:defRPr>
+    </a:lvl4pPr>
+    <a:lvl5pPr marL="1828800" algn="l" defTabSz="914400" rtl="0" eaLnBrk="1" latinLnBrk="0" hangingPunct="1">
+      <a:defRPr sz="1200" kern="1200">
+        <a:solidFill>
+          <a:schemeClr val="tx1"/>
+        </a:solidFill>
+        <a:latin typeface="+mn-lt"/>
+        <a:ea typeface="+mn-ea"/>
+        <a:cs typeface="+mn-cs"/>
+      </a:defRPr>
+    </a:lvl5pPr>
+    <a:lvl6pPr marL="2286000" algn="l" defTabSz="914400" rtl="0" eaLnBrk="1" latinLnBrk="0" hangingPunct="1">
+      <a:defRPr sz="1200" kern="1200">
+        <a:solidFill>
+          <a:schemeClr val="tx1"/>
+        </a:solidFill>
+        <a:latin typeface="+mn-lt"/>
+        <a:ea typeface="+mn-ea"/>
+        <a:cs typeface="+mn-cs"/>
+      </a:defRPr>
+    </a:lvl6pPr>
+    <a:lvl7pPr marL="2743200" algn="l" defTabSz="914400" rtl="0" eaLnBrk="1" latinLnBrk="0" hangingPunct="1">
+      <a:defRPr sz="1200" kern="1200">
+        <a:solidFill>
+          <a:schemeClr val="tx1"/>
+        </a:solidFill>
+        <a:latin typeface="+mn-lt"/>
+        <a:ea typeface="+mn-ea"/>
+        <a:cs typeface="+mn-cs"/>
+      </a:defRPr>
+    </a:lvl7pPr>
+    <a:lvl8pPr marL="3200400" algn="l" defTabSz="914400" rtl="0" eaLnBrk="1" latinLnBrk="0" hangingPunct="1">
+      <a:defRPr sz="1200" kern="1200">
+        <a:solidFill>
+          <a:schemeClr val="tx1"/>
+        </a:solidFill>
+        <a:latin typeface="+mn-lt"/>
+        <a:ea typeface="+mn-ea"/>
+        <a:cs typeface="+mn-cs"/>
+      </a:defRPr>
+    </a:lvl8pPr>
+    <a:lvl9pPr marL="3657600" algn="l" defTabSz="914400" rtl="0" eaLnBrk="1" latinLnBrk="0" hangingPunct="1">
+      <a:defRPr sz="1200" kern="1200">
+        <a:solidFill>
+          <a:schemeClr val="tx1"/>
+        </a:solidFill>
+        <a:latin typeface="+mn-lt"/>
+        <a:ea typeface="+mn-ea"/>
+        <a:cs typeface="+mn-cs"/>
+      </a:defRPr>
+    </a:lvl9pPr>
+  </p:notesStyle>
+</p:notesMaster>
+</file>
+
+<file path=ppt/notesSlides/notesSlide1.xml><?xml version="1.0" encoding="utf-8"?>
+<p:notes xmlns:a="http://schemas.openxmlformats.org/drawingml/2006/main" xmlns:r="http://schemas.openxmlformats.org/officeDocument/2006/relationships" xmlns:p="http://schemas.openxmlformats.org/presentationml/2006/main">
+  <p:cSld>
+    <p:spTree>
+      <p:nvGrpSpPr>
+        <p:cNvPr id="1" name=""/>
+        <p:cNvGrpSpPr/>
+        <p:nvPr/>
+      </p:nvGrpSpPr>
+      <p:grpSpPr>
+        <a:xfrm>
+          <a:off x="0" y="0"/>
+          <a:ext cx="0" cy="0"/>
+          <a:chOff x="0" y="0"/>
+          <a:chExt cx="0" cy="0"/>
+        </a:xfrm>
+      </p:grpSpPr>
+      <p:sp>
+        <p:nvSpPr>
+          <p:cNvPr id="2" name="Slide Image Placeholder 1"/>
+          <p:cNvSpPr>
+            <a:spLocks noGrp="1" noRot="1" noChangeAspect="1"/>
+          </p:cNvSpPr>
+          <p:nvPr>
+            <p:ph type="sldImg"/>
+          </p:nvPr>
+        </p:nvSpPr>
+        <p:spPr/>
+      </p:sp>
+      <p:sp>
+        <p:nvSpPr>
+          <p:cNvPr id="3" name="Notes Placeholder 2"/>
+          <p:cNvSpPr>
+            <a:spLocks noGrp="1"/>
+          </p:cNvSpPr>
+          <p:nvPr>
+            <p:ph type="body" idx="1"/>
+          </p:nvPr>
+        </p:nvSpPr>
+        <p:spPr/>
+        <p:txBody>
+          <a:bodyPr/>
+          <a:lstStyle/>
+          <a:p>
+            <a:endParaRPr lang="en-US" dirty="0"/>
+          </a:p>
+        </p:txBody>
+      </p:sp>
+      <p:sp>
+        <p:nvSpPr>
+          <p:cNvPr id="4" name="Slide Number Placeholder 3"/>
+          <p:cNvSpPr>
+            <a:spLocks noGrp="1"/>
+          </p:cNvSpPr>
+          <p:nvPr>
+            <p:ph type="sldNum" sz="quarter" idx="10"/>
+          </p:nvPr>
+        </p:nvSpPr>
+        <p:spPr/>
+        <p:txBody>
+          <a:bodyPr/>
+          <a:lstStyle/>
+          <a:p>
+            <a:fld id="{8697A498-47AA-1043-BA67-9567D7B7BA32}" type="slidenum">
+              <a:rPr lang="en-US" smtClean="0"/>
+              <a:t>11</a:t>
+            </a:fld>
+            <a:endParaRPr lang="en-US"/>
+          </a:p>
+        </p:txBody>
+      </p:sp>
+    </p:spTree>
+    <p:extLst>
+      <p:ext uri="{BB962C8B-B14F-4D97-AF65-F5344CB8AC3E}">
+        <p14:creationId xmlns:p14="http://schemas.microsoft.com/office/powerpoint/2010/main" val="2893114229"/>
+      </p:ext>
+    </p:extLst>
+  </p:cSld>
+  <p:clrMapOvr>
+    <a:masterClrMapping/>
+  </p:clrMapOvr>
+</p:notes>
+</file>
+
 <file path=ppt/slideLayouts/slideLayout1.xml><?xml version="1.0" encoding="utf-8"?>
 <p:sldLayout xmlns:a="http://schemas.openxmlformats.org/drawingml/2006/main" xmlns:r="http://schemas.openxmlformats.org/officeDocument/2006/relationships" xmlns:p="http://schemas.openxmlformats.org/presentationml/2006/main" type="title" preserve="1">
   <p:cSld name="Title Slide">
@@ -313,7 +749,7 @@
           <a:p>
             <a:fld id="{5BCAD085-E8A6-8845-BD4E-CB4CCA059FC4}" type="datetimeFigureOut">
               <a:rPr lang="en-US" smtClean="0"/>
-              <a:t>6/21/26</a:t>
+              <a:t>6/22/26</a:t>
             </a:fld>
             <a:endParaRPr lang="en-US"/>
           </a:p>
@@ -481,7 +917,7 @@
           <a:p>
             <a:fld id="{5BCAD085-E8A6-8845-BD4E-CB4CCA059FC4}" type="datetimeFigureOut">
               <a:rPr lang="en-US" smtClean="0"/>
-              <a:t>6/21/26</a:t>
+              <a:t>6/22/26</a:t>
             </a:fld>
             <a:endParaRPr lang="en-US"/>
           </a:p>
@@ -659,7 +1095,7 @@
           <a:p>
             <a:fld id="{5BCAD085-E8A6-8845-BD4E-CB4CCA059FC4}" type="datetimeFigureOut">
               <a:rPr lang="en-US" smtClean="0"/>
-              <a:t>6/21/26</a:t>
+              <a:t>6/22/26</a:t>
             </a:fld>
             <a:endParaRPr lang="en-US"/>
           </a:p>
@@ -827,7 +1263,7 @@
           <a:p>
             <a:fld id="{5BCAD085-E8A6-8845-BD4E-CB4CCA059FC4}" type="datetimeFigureOut">
               <a:rPr lang="en-US" smtClean="0"/>
-              <a:t>6/21/26</a:t>
+              <a:t>6/22/26</a:t>
             </a:fld>
             <a:endParaRPr lang="en-US"/>
           </a:p>
@@ -1072,7 +1508,7 @@
           <a:p>
             <a:fld id="{5BCAD085-E8A6-8845-BD4E-CB4CCA059FC4}" type="datetimeFigureOut">
               <a:rPr lang="en-US" smtClean="0"/>
-              <a:t>6/21/26</a:t>
+              <a:t>6/22/26</a:t>
             </a:fld>
             <a:endParaRPr lang="en-US"/>
           </a:p>
@@ -1357,7 +1793,7 @@
           <a:p>
             <a:fld id="{5BCAD085-E8A6-8845-BD4E-CB4CCA059FC4}" type="datetimeFigureOut">
               <a:rPr lang="en-US" smtClean="0"/>
-              <a:t>6/21/26</a:t>
+              <a:t>6/22/26</a:t>
             </a:fld>
             <a:endParaRPr lang="en-US"/>
           </a:p>
@@ -1776,7 +2212,7 @@
           <a:p>
             <a:fld id="{5BCAD085-E8A6-8845-BD4E-CB4CCA059FC4}" type="datetimeFigureOut">
               <a:rPr lang="en-US" smtClean="0"/>
-              <a:t>6/21/26</a:t>
+              <a:t>6/22/26</a:t>
             </a:fld>
             <a:endParaRPr lang="en-US"/>
           </a:p>
@@ -1893,7 +2329,7 @@
           <a:p>
             <a:fld id="{5BCAD085-E8A6-8845-BD4E-CB4CCA059FC4}" type="datetimeFigureOut">
               <a:rPr lang="en-US" smtClean="0"/>
-              <a:t>6/21/26</a:t>
+              <a:t>6/22/26</a:t>
             </a:fld>
             <a:endParaRPr lang="en-US"/>
           </a:p>
@@ -1988,7 +2424,7 @@
           <a:p>
             <a:fld id="{5BCAD085-E8A6-8845-BD4E-CB4CCA059FC4}" type="datetimeFigureOut">
               <a:rPr lang="en-US" smtClean="0"/>
-              <a:t>6/21/26</a:t>
+              <a:t>6/22/26</a:t>
             </a:fld>
             <a:endParaRPr lang="en-US"/>
           </a:p>
@@ -2263,7 +2699,7 @@
           <a:p>
             <a:fld id="{5BCAD085-E8A6-8845-BD4E-CB4CCA059FC4}" type="datetimeFigureOut">
               <a:rPr lang="en-US" smtClean="0"/>
-              <a:t>6/21/26</a:t>
+              <a:t>6/22/26</a:t>
             </a:fld>
             <a:endParaRPr lang="en-US"/>
           </a:p>
@@ -2515,7 +2951,7 @@
           <a:p>
             <a:fld id="{5BCAD085-E8A6-8845-BD4E-CB4CCA059FC4}" type="datetimeFigureOut">
               <a:rPr lang="en-US" smtClean="0"/>
-              <a:t>6/21/26</a:t>
+              <a:t>6/22/26</a:t>
             </a:fld>
             <a:endParaRPr lang="en-US"/>
           </a:p>
@@ -2726,7 +3162,7 @@
           <a:p>
             <a:fld id="{5BCAD085-E8A6-8845-BD4E-CB4CCA059FC4}" type="datetimeFigureOut">
               <a:rPr lang="en-US" smtClean="0"/>
-              <a:t>6/21/26</a:t>
+              <a:t>6/22/26</a:t>
             </a:fld>
             <a:endParaRPr lang="en-US"/>
           </a:p>
@@ -3546,7 +3982,7 @@
         <p:spPr>
           <a:xfrm>
             <a:off x="6583680" y="1920240"/>
-            <a:ext cx="4572000" cy="3123932"/>
+            <a:ext cx="4572000" cy="3339376"/>
           </a:xfrm>
           <a:prstGeom prst="rect">
             <a:avLst/>
@@ -3690,7 +4126,7 @@
             </a:pPr>
             <a:r>
               <a:rPr lang="en-US" sz="1400" dirty="0"/>
-              <a:t>      - Live turn-by-turn mobile app sync. Deploy towing fleet size matching.</a:t>
+              <a:t>      - Live turn-by-turn mobile app sync. Deploy towing fleet size 	matching.</a:t>
             </a:r>
           </a:p>
           <a:p>
@@ -3844,7 +4280,7 @@
           <p:nvPr/>
         </p:nvPicPr>
         <p:blipFill>
-          <a:blip r:embed="rId2"/>
+          <a:blip r:embed="rId3"/>
           <a:stretch>
             <a:fillRect/>
           </a:stretch>
@@ -4277,7 +4713,7 @@
                     <a:lumOff val="5000"/>
                   </a:schemeClr>
                 </a:solidFill>
-                <a:hlinkClick r:id="rId3"/>
+                <a:hlinkClick r:id="rId4"/>
               </a:rPr>
               <a:t>https://sb01022006.github.io/ai-parking-congestion-intelligence/</a:t>
             </a:r>
@@ -4321,7 +4757,7 @@
                     <a:lumOff val="5000"/>
                   </a:schemeClr>
                 </a:solidFill>
-                <a:hlinkClick r:id="rId4"/>
+                <a:hlinkClick r:id="rId5"/>
               </a:rPr>
               <a:t>https://ai-parking-congestion-intelligence.onrender.com</a:t>
             </a:r>
@@ -4365,7 +4801,7 @@
                     <a:lumOff val="5000"/>
                   </a:schemeClr>
                 </a:solidFill>
-                <a:hlinkClick r:id="rId5"/>
+                <a:hlinkClick r:id="rId6"/>
               </a:rPr>
               <a:t>https://github.com/sb01022006/ai-parking-congestion-intelligence</a:t>
             </a:r>
@@ -4409,7 +4845,7 @@
                     <a:lumOff val="5000"/>
                   </a:schemeClr>
                 </a:solidFill>
-                <a:hlinkClick r:id="rId6"/>
+                <a:hlinkClick r:id="rId7"/>
               </a:rPr>
               <a:t>https://drive.google.com/file/d/1BrF4HMsvkTWnxRqcdl6Lb8lGopAEfH8V/view</a:t>
             </a:r>
@@ -5734,7 +6170,7 @@
         <p:spPr>
           <a:xfrm>
             <a:off x="6583680" y="1920240"/>
-            <a:ext cx="4572000" cy="3483005"/>
+            <a:ext cx="4572000" cy="3236784"/>
           </a:xfrm>
           <a:prstGeom prst="rect">
             <a:avLst/>
@@ -5826,8 +6262,12 @@
               </a:defRPr>
             </a:pPr>
             <a:r>
+              <a:rPr sz="1600" b="1" dirty="0"/>
+              <a:t>•</a:t>
+            </a:r>
+            <a:r>
               <a:rPr sz="1600" b="1" u="sng" dirty="0"/>
-              <a:t>• AI Patrol Route Pathfinder: </a:t>
+              <a:t> AI Patrol Route Pathfinder: </a:t>
             </a:r>
             <a:r>
               <a:rPr sz="1600" dirty="0"/>
@@ -6174,8 +6614,8 @@
               <a:t>Enforcement is reactive; no </a:t>
             </a:r>
             <a:r>
-              <a:rPr sz="1600" dirty="0" err="1"/>
-              <a:t>heatmap</a:t>
+              <a:rPr lang="en-US" sz="1600" dirty="0"/>
+              <a:t>heat map</a:t>
             </a:r>
             <a:r>
               <a:rPr sz="1600" dirty="0"/>
@@ -7057,15 +7497,15 @@
               <a:t>• </a:t>
             </a:r>
             <a:r>
-              <a:rPr sz="1600" b="1" u="sng" dirty="0"/>
+              <a:rPr sz="1600" b="1" dirty="0"/>
               <a:t>We propose </a:t>
             </a:r>
             <a:r>
-              <a:rPr sz="1600" b="1" u="sng" dirty="0" err="1"/>
+              <a:rPr sz="1600" b="1" dirty="0" err="1"/>
               <a:t>VeloCity</a:t>
             </a:r>
             <a:r>
-              <a:rPr sz="1600" b="1" u="sng" dirty="0"/>
+              <a:rPr sz="1600" b="1" dirty="0"/>
               <a:t>: </a:t>
             </a:r>
             <a:r>
@@ -7088,6 +7528,10 @@
             <a:r>
               <a:rPr sz="1600" dirty="0"/>
               <a:t>• Rather than scheduling uniform warden patrols, </a:t>
+            </a:r>
+            <a:r>
+              <a:rPr lang="en-US" sz="1600" dirty="0"/>
+              <a:t>  </a:t>
             </a:r>
             <a:r>
               <a:rPr sz="1600" dirty="0" err="1"/>
@@ -7212,11 +7656,19 @@
             </a:r>
             <a:r>
               <a:rPr sz="1600" dirty="0"/>
-              <a:t>- Cleans 298,450 records, converting UTC to IST to map daytime </a:t>
+              <a:t>- Cleans 298,450 records, converting UTC to IST to </a:t>
             </a:r>
             <a:r>
               <a:rPr lang="en-US" sz="1600" dirty="0"/>
-              <a:t>	</a:t>
+              <a:t>	   </a:t>
+            </a:r>
+            <a:r>
+              <a:rPr sz="1600" dirty="0"/>
+              <a:t>map daytime</a:t>
+            </a:r>
+            <a:r>
+              <a:rPr lang="en-US" sz="1600" dirty="0"/>
+              <a:t> </a:t>
             </a:r>
             <a:r>
               <a:rPr sz="1600" dirty="0"/>
@@ -7266,15 +7718,15 @@
             </a:r>
             <a:r>
               <a:rPr sz="1600" dirty="0"/>
-              <a:t>- Computes localized grids severity dynamically using dispatcher </a:t>
+              <a:t>- Computes localized grids severity dynamically </a:t>
             </a:r>
             <a:r>
               <a:rPr lang="en-US" sz="1600" dirty="0"/>
-              <a:t>	</a:t>
+              <a:t>	  	   </a:t>
             </a:r>
             <a:r>
               <a:rPr sz="1600" dirty="0"/>
-              <a:t>sliders.</a:t>
+              <a:t>using dispatcher sliders.</a:t>
             </a:r>
           </a:p>
           <a:p>
@@ -7324,15 +7776,19 @@
             </a:r>
             <a:r>
               <a:rPr sz="1600" dirty="0"/>
-              <a:t>- Solves Exact TSP tour in &lt;1ms and snaps routes to roads using OSRM for wardens.</a:t>
+              <a:t>- Solves Exact TSP tour in &lt;1ms and snaps routes </a:t>
+            </a:r>
+            <a:r>
+              <a:rPr lang="en-US" sz="1600" dirty="0"/>
+              <a:t>	 	   </a:t>
+            </a:r>
+            <a:r>
+              <a:rPr sz="1600" dirty="0"/>
+              <a:t>to roads using OSRM for wardens.</a:t>
             </a:r>
             <a:r>
               <a:rPr lang="en-US" sz="1600" dirty="0"/>
               <a:t>	</a:t>
-            </a:r>
-            <a:r>
-              <a:rPr sz="1600" dirty="0"/>
-              <a:t/>
             </a:r>
           </a:p>
         </p:txBody>
@@ -8145,7 +8601,7 @@
         <p:spPr>
           <a:xfrm>
             <a:off x="1005840" y="1920240"/>
-            <a:ext cx="4572000" cy="3693319"/>
+            <a:ext cx="4572000" cy="3893374"/>
           </a:xfrm>
           <a:prstGeom prst="rect">
             <a:avLst/>
@@ -8371,15 +8827,15 @@
             </a:r>
             <a:r>
               <a:rPr sz="1300" dirty="0"/>
-              <a:t> - </a:t>
+              <a:t> - Solves Traveling Salesperson Problem (TSP) exactly to find the </a:t>
             </a:r>
             <a:r>
               <a:rPr lang="en-US" sz="1300" dirty="0"/>
-              <a:t/>
+              <a:t>	</a:t>
             </a:r>
             <a:r>
               <a:rPr sz="1300" dirty="0"/>
-              <a:t>Solves Traveling Salesperson Problem (TSP) exactly to find the absolute shortest round tour.</a:t>
+              <a:t>absolute shortest round tour.</a:t>
             </a:r>
           </a:p>
           <a:p>
@@ -8400,7 +8856,15 @@
             </a:r>
             <a:r>
               <a:rPr sz="1300" dirty="0"/>
-              <a:t>- Snaps path to live road geometry via OSRM, including real turn-by-turn navigation.</a:t>
+              <a:t>- Snaps path to live road geometry via OSRM, including real turn-</a:t>
+            </a:r>
+            <a:r>
+              <a:rPr lang="en-US" sz="1300" dirty="0"/>
+              <a:t>	</a:t>
+            </a:r>
+            <a:r>
+              <a:rPr sz="1300" dirty="0"/>
+              <a:t>by-turn navigation.</a:t>
             </a:r>
           </a:p>
           <a:p>
@@ -9992,4 +10456,299 @@
   </a:objectDefaults>
   <a:extraClrSchemeLst/>
 </a:theme>
+</file>
+
+<file path=ppt/theme/theme2.xml><?xml version="1.0" encoding="utf-8"?>
+<a:theme xmlns:a="http://schemas.openxmlformats.org/drawingml/2006/main" name="Office Theme">
+  <a:themeElements>
+    <a:clrScheme name="Office">
+      <a:dk1>
+        <a:sysClr val="windowText" lastClr="000000"/>
+      </a:dk1>
+      <a:lt1>
+        <a:sysClr val="window" lastClr="FFFFFF"/>
+      </a:lt1>
+      <a:dk2>
+        <a:srgbClr val="44546A"/>
+      </a:dk2>
+      <a:lt2>
+        <a:srgbClr val="E7E6E6"/>
+      </a:lt2>
+      <a:accent1>
+        <a:srgbClr val="4472C4"/>
+      </a:accent1>
+      <a:accent2>
+        <a:srgbClr val="ED7D31"/>
+      </a:accent2>
+      <a:accent3>
+        <a:srgbClr val="A5A5A5"/>
+      </a:accent3>
+      <a:accent4>
+        <a:srgbClr val="FFC000"/>
+      </a:accent4>
+      <a:accent5>
+        <a:srgbClr val="5B9BD5"/>
+      </a:accent5>
+      <a:accent6>
+        <a:srgbClr val="70AD47"/>
+      </a:accent6>
+      <a:hlink>
+        <a:srgbClr val="0563C1"/>
+      </a:hlink>
+      <a:folHlink>
+        <a:srgbClr val="954F72"/>
+      </a:folHlink>
+    </a:clrScheme>
+    <a:fontScheme name="Office">
+      <a:majorFont>
+        <a:latin typeface="Calibri Light" panose="020F0302020204030204"/>
+        <a:ea typeface=""/>
+        <a:cs typeface=""/>
+        <a:font script="Jpan" typeface="游ゴシック Light"/>
+        <a:font script="Hang" typeface="맑은 고딕"/>
+        <a:font script="Hans" typeface="等线 Light"/>
+        <a:font script="Hant" typeface="新細明體"/>
+        <a:font script="Arab" typeface="Times New Roman"/>
+        <a:font script="Hebr" typeface="Times New Roman"/>
+        <a:font script="Thai" typeface="Angsana New"/>
+        <a:font script="Ethi" typeface="Nyala"/>
+        <a:font script="Beng" typeface="Vrinda"/>
+        <a:font script="Gujr" typeface="Shruti"/>
+        <a:font script="Khmr" typeface="MoolBoran"/>
+        <a:font script="Knda" typeface="Tunga"/>
+        <a:font script="Guru" typeface="Raavi"/>
+        <a:font script="Cans" typeface="Euphemia"/>
+        <a:font script="Cher" typeface="Plantagenet Cherokee"/>
+        <a:font script="Yiii" typeface="Microsoft Yi Baiti"/>
+        <a:font script="Tibt" typeface="Microsoft Himalaya"/>
+        <a:font script="Thaa" typeface="MV Boli"/>
+        <a:font script="Deva" typeface="Mangal"/>
+        <a:font script="Telu" typeface="Gautami"/>
+        <a:font script="Taml" typeface="Latha"/>
+        <a:font script="Syrc" typeface="Estrangelo Edessa"/>
+        <a:font script="Orya" typeface="Kalinga"/>
+        <a:font script="Mlym" typeface="Kartika"/>
+        <a:font script="Laoo" typeface="DokChampa"/>
+        <a:font script="Sinh" typeface="Iskoola Pota"/>
+        <a:font script="Mong" typeface="Mongolian Baiti"/>
+        <a:font script="Viet" typeface="Times New Roman"/>
+        <a:font script="Uigh" typeface="Microsoft Uighur"/>
+        <a:font script="Geor" typeface="Sylfaen"/>
+        <a:font script="Armn" typeface="Arial"/>
+        <a:font script="Bugi" typeface="Leelawadee UI"/>
+        <a:font script="Bopo" typeface="Microsoft JhengHei"/>
+        <a:font script="Java" typeface="Javanese Text"/>
+        <a:font script="Lisu" typeface="Segoe UI"/>
+        <a:font script="Mymr" typeface="Myanmar Text"/>
+        <a:font script="Nkoo" typeface="Ebrima"/>
+        <a:font script="Olck" typeface="Nirmala UI"/>
+        <a:font script="Osma" typeface="Ebrima"/>
+        <a:font script="Phag" typeface="Phagspa"/>
+        <a:font script="Syrn" typeface="Estrangelo Edessa"/>
+        <a:font script="Syrj" typeface="Estrangelo Edessa"/>
+        <a:font script="Syre" typeface="Estrangelo Edessa"/>
+        <a:font script="Sora" typeface="Nirmala UI"/>
+        <a:font script="Tale" typeface="Microsoft Tai Le"/>
+        <a:font script="Talu" typeface="Microsoft New Tai Lue"/>
+        <a:font script="Tfng" typeface="Ebrima"/>
+      </a:majorFont>
+      <a:minorFont>
+        <a:latin typeface="Calibri" panose="020F0502020204030204"/>
+        <a:ea typeface=""/>
+        <a:cs typeface=""/>
+        <a:font script="Jpan" typeface="游ゴシック"/>
+        <a:font script="Hang" typeface="맑은 고딕"/>
+        <a:font script="Hans" typeface="等线"/>
+        <a:font script="Hant" typeface="新細明體"/>
+        <a:font script="Arab" typeface="Arial"/>
+        <a:font script="Hebr" typeface="Arial"/>
+        <a:font script="Thai" typeface="Cordia New"/>
+        <a:font script="Ethi" typeface="Nyala"/>
+        <a:font script="Beng" typeface="Vrinda"/>
+        <a:font script="Gujr" typeface="Shruti"/>
+        <a:font script="Khmr" typeface="DaunPenh"/>
+        <a:font script="Knda" typeface="Tunga"/>
+        <a:font script="Guru" typeface="Raavi"/>
+        <a:font script="Cans" typeface="Euphemia"/>
+        <a:font script="Cher" typeface="Plantagenet Cherokee"/>
+        <a:font script="Yiii" typeface="Microsoft Yi Baiti"/>
+        <a:font script="Tibt" typeface="Microsoft Himalaya"/>
+        <a:font script="Thaa" typeface="MV Boli"/>
+        <a:font script="Deva" typeface="Mangal"/>
+        <a:font script="Telu" typeface="Gautami"/>
+        <a:font script="Taml" typeface="Latha"/>
+        <a:font script="Syrc" typeface="Estrangelo Edessa"/>
+        <a:font script="Orya" typeface="Kalinga"/>
+        <a:font script="Mlym" typeface="Kartika"/>
+        <a:font script="Laoo" typeface="DokChampa"/>
+        <a:font script="Sinh" typeface="Iskoola Pota"/>
+        <a:font script="Mong" typeface="Mongolian Baiti"/>
+        <a:font script="Viet" typeface="Arial"/>
+        <a:font script="Uigh" typeface="Microsoft Uighur"/>
+        <a:font script="Geor" typeface="Sylfaen"/>
+        <a:font script="Armn" typeface="Arial"/>
+        <a:font script="Bugi" typeface="Leelawadee UI"/>
+        <a:font script="Bopo" typeface="Microsoft JhengHei"/>
+        <a:font script="Java" typeface="Javanese Text"/>
+        <a:font script="Lisu" typeface="Segoe UI"/>
+        <a:font script="Mymr" typeface="Myanmar Text"/>
+        <a:font script="Nkoo" typeface="Ebrima"/>
+        <a:font script="Olck" typeface="Nirmala UI"/>
+        <a:font script="Osma" typeface="Ebrima"/>
+        <a:font script="Phag" typeface="Phagspa"/>
+        <a:font script="Syrn" typeface="Estrangelo Edessa"/>
+        <a:font script="Syrj" typeface="Estrangelo Edessa"/>
+        <a:font script="Syre" typeface="Estrangelo Edessa"/>
+        <a:font script="Sora" typeface="Nirmala UI"/>
+        <a:font script="Tale" typeface="Microsoft Tai Le"/>
+        <a:font script="Talu" typeface="Microsoft New Tai Lue"/>
+        <a:font script="Tfng" typeface="Ebrima"/>
+      </a:minorFont>
+    </a:fontScheme>
+    <a:fmtScheme name="Office">
+      <a:fillStyleLst>
+        <a:solidFill>
+          <a:schemeClr val="phClr"/>
+        </a:solidFill>
+        <a:gradFill rotWithShape="1">
+          <a:gsLst>
+            <a:gs pos="0">
+              <a:schemeClr val="phClr">
+                <a:lumMod val="110000"/>
+                <a:satMod val="105000"/>
+                <a:tint val="67000"/>
+              </a:schemeClr>
+            </a:gs>
+            <a:gs pos="50000">
+              <a:schemeClr val="phClr">
+                <a:lumMod val="105000"/>
+                <a:satMod val="103000"/>
+                <a:tint val="73000"/>
+              </a:schemeClr>
+            </a:gs>
+            <a:gs pos="100000">
+              <a:schemeClr val="phClr">
+                <a:lumMod val="105000"/>
+                <a:satMod val="109000"/>
+                <a:tint val="81000"/>
+              </a:schemeClr>
+            </a:gs>
+          </a:gsLst>
+          <a:lin ang="5400000" scaled="0"/>
+        </a:gradFill>
+        <a:gradFill rotWithShape="1">
+          <a:gsLst>
+            <a:gs pos="0">
+              <a:schemeClr val="phClr">
+                <a:satMod val="103000"/>
+                <a:lumMod val="102000"/>
+                <a:tint val="94000"/>
+              </a:schemeClr>
+            </a:gs>
+            <a:gs pos="50000">
+              <a:schemeClr val="phClr">
+                <a:satMod val="110000"/>
+                <a:lumMod val="100000"/>
+                <a:shade val="100000"/>
+              </a:schemeClr>
+            </a:gs>
+            <a:gs pos="100000">
+              <a:schemeClr val="phClr">
+                <a:lumMod val="99000"/>
+                <a:satMod val="120000"/>
+                <a:shade val="78000"/>
+              </a:schemeClr>
+            </a:gs>
+          </a:gsLst>
+          <a:lin ang="5400000" scaled="0"/>
+        </a:gradFill>
+      </a:fillStyleLst>
+      <a:lnStyleLst>
+        <a:ln w="6350" cap="flat" cmpd="sng" algn="ctr">
+          <a:solidFill>
+            <a:schemeClr val="phClr"/>
+          </a:solidFill>
+          <a:prstDash val="solid"/>
+          <a:miter lim="800000"/>
+        </a:ln>
+        <a:ln w="12700" cap="flat" cmpd="sng" algn="ctr">
+          <a:solidFill>
+            <a:schemeClr val="phClr"/>
+          </a:solidFill>
+          <a:prstDash val="solid"/>
+          <a:miter lim="800000"/>
+        </a:ln>
+        <a:ln w="19050" cap="flat" cmpd="sng" algn="ctr">
+          <a:solidFill>
+            <a:schemeClr val="phClr"/>
+          </a:solidFill>
+          <a:prstDash val="solid"/>
+          <a:miter lim="800000"/>
+        </a:ln>
+      </a:lnStyleLst>
+      <a:effectStyleLst>
+        <a:effectStyle>
+          <a:effectLst/>
+        </a:effectStyle>
+        <a:effectStyle>
+          <a:effectLst/>
+        </a:effectStyle>
+        <a:effectStyle>
+          <a:effectLst>
+            <a:outerShdw blurRad="57150" dist="19050" dir="5400000" algn="ctr" rotWithShape="0">
+              <a:srgbClr val="000000">
+                <a:alpha val="63000"/>
+              </a:srgbClr>
+            </a:outerShdw>
+          </a:effectLst>
+        </a:effectStyle>
+      </a:effectStyleLst>
+      <a:bgFillStyleLst>
+        <a:solidFill>
+          <a:schemeClr val="phClr"/>
+        </a:solidFill>
+        <a:solidFill>
+          <a:schemeClr val="phClr">
+            <a:tint val="95000"/>
+            <a:satMod val="170000"/>
+          </a:schemeClr>
+        </a:solidFill>
+        <a:gradFill rotWithShape="1">
+          <a:gsLst>
+            <a:gs pos="0">
+              <a:schemeClr val="phClr">
+                <a:tint val="93000"/>
+                <a:satMod val="150000"/>
+                <a:shade val="98000"/>
+                <a:lumMod val="102000"/>
+              </a:schemeClr>
+            </a:gs>
+            <a:gs pos="50000">
+              <a:schemeClr val="phClr">
+                <a:tint val="98000"/>
+                <a:satMod val="130000"/>
+                <a:shade val="90000"/>
+                <a:lumMod val="103000"/>
+              </a:schemeClr>
+            </a:gs>
+            <a:gs pos="100000">
+              <a:schemeClr val="phClr">
+                <a:shade val="63000"/>
+                <a:satMod val="120000"/>
+              </a:schemeClr>
+            </a:gs>
+          </a:gsLst>
+          <a:lin ang="5400000" scaled="0"/>
+        </a:gradFill>
+      </a:bgFillStyleLst>
+    </a:fmtScheme>
+  </a:themeElements>
+  <a:objectDefaults/>
+  <a:extraClrSchemeLst/>
+  <a:extLst>
+    <a:ext uri="{05A4C25C-085E-4340-85A3-A5531E510DB2}">
+      <thm15:themeFamily xmlns:thm15="http://schemas.microsoft.com/office/thememl/2012/main" name="Office Theme" id="{62F939B6-93AF-4DB8-9C6B-D6C7DFDC589F}" vid="{4A3C46E8-61CC-4603-A589-7422A47A8E4A}"/>
+    </a:ext>
+  </a:extLst>
+</a:theme>
 </file>
</xml_diff>

<commit_message>
Add GPS Turn-by-Turn Navigation references to Slides 3, 6, and 7
</commit_message>
<xml_diff>
--- a/Flikart_Grid_Lock_hackathon_Round_2_Confluent.pptx
+++ b/Flikart_Grid_Lock_hackathon_Round_2_Confluent.pptx
@@ -7771,24 +7771,7 @@
               </a:defRPr>
             </a:pPr>
             <a:r>
-              <a:rPr lang="en-US" sz="1600" dirty="0"/>
-              <a:t>	</a:t>
-            </a:r>
-            <a:r>
-              <a:rPr sz="1600" dirty="0"/>
-              <a:t>- Solves Exact TSP tour in &lt;1ms and snaps routes </a:t>
-            </a:r>
-            <a:r>
-              <a:rPr lang="en-US" sz="1600" dirty="0"/>
-              <a:t>	 	   </a:t>
-            </a:r>
-            <a:r>
-              <a:rPr sz="1600" dirty="0"/>
-              <a:t>to roads using OSRM for wardens.</a:t>
-            </a:r>
-            <a:r>
-              <a:rPr lang="en-US" sz="1600" dirty="0"/>
-              <a:t>	</a:t>
+              <a:t>	- Solves Exact TSP tour in &lt;1ms, snaps routes to roads using OSRM, and generates GPS turn-by-turn navigation for wardens.</a:t>
             </a:r>
           </a:p>
         </p:txBody>
@@ -8097,16 +8080,8 @@
                     <a:bodyPr/>
                     <a:lstStyle/>
                     <a:p>
-                      <a:pPr algn="ctr">
-                        <a:defRPr sz="1300" b="0">
-                          <a:solidFill>
-                            <a:srgbClr val="0F172A"/>
-                          </a:solidFill>
-                          <a:latin typeface="Calibri"/>
-                        </a:defRPr>
-                      </a:pPr>
                       <a:r>
-                        <a:t>Provides a fast, component-based mapping UI with custom Leaflet markers, polyline routes, and slider panels.</a:t>
+                        <a:t>Provides a fast, component-based mapping UI with custom Leaflet markers, snapped routes, and a live GPS turn-by-turn navigation panel.</a:t>
                       </a:r>
                     </a:p>
                   </a:txBody>

</xml_diff>

<commit_message>
Update Slide 3 to include GPS turn-by-turn navigation description
</commit_message>
<xml_diff>
--- a/Flikart_Grid_Lock_hackathon_Round_2_Confluent.pptx
+++ b/Flikart_Grid_Lock_hackathon_Round_2_Confluent.pptx
@@ -219,7 +219,7 @@
           <a:p>
             <a:fld id="{5C8CBD25-6209-B341-A3EB-3CFC2FF39C7A}" type="datetimeFigureOut">
               <a:rPr lang="en-US" smtClean="0"/>
-              <a:t>6/22/26</a:t>
+              <a:t>6/23/26</a:t>
             </a:fld>
             <a:endParaRPr lang="en-US"/>
           </a:p>
@@ -749,7 +749,7 @@
           <a:p>
             <a:fld id="{5BCAD085-E8A6-8845-BD4E-CB4CCA059FC4}" type="datetimeFigureOut">
               <a:rPr lang="en-US" smtClean="0"/>
-              <a:t>6/22/26</a:t>
+              <a:t>6/23/26</a:t>
             </a:fld>
             <a:endParaRPr lang="en-US"/>
           </a:p>
@@ -917,7 +917,7 @@
           <a:p>
             <a:fld id="{5BCAD085-E8A6-8845-BD4E-CB4CCA059FC4}" type="datetimeFigureOut">
               <a:rPr lang="en-US" smtClean="0"/>
-              <a:t>6/22/26</a:t>
+              <a:t>6/23/26</a:t>
             </a:fld>
             <a:endParaRPr lang="en-US"/>
           </a:p>
@@ -1095,7 +1095,7 @@
           <a:p>
             <a:fld id="{5BCAD085-E8A6-8845-BD4E-CB4CCA059FC4}" type="datetimeFigureOut">
               <a:rPr lang="en-US" smtClean="0"/>
-              <a:t>6/22/26</a:t>
+              <a:t>6/23/26</a:t>
             </a:fld>
             <a:endParaRPr lang="en-US"/>
           </a:p>
@@ -1263,7 +1263,7 @@
           <a:p>
             <a:fld id="{5BCAD085-E8A6-8845-BD4E-CB4CCA059FC4}" type="datetimeFigureOut">
               <a:rPr lang="en-US" smtClean="0"/>
-              <a:t>6/22/26</a:t>
+              <a:t>6/23/26</a:t>
             </a:fld>
             <a:endParaRPr lang="en-US"/>
           </a:p>
@@ -1508,7 +1508,7 @@
           <a:p>
             <a:fld id="{5BCAD085-E8A6-8845-BD4E-CB4CCA059FC4}" type="datetimeFigureOut">
               <a:rPr lang="en-US" smtClean="0"/>
-              <a:t>6/22/26</a:t>
+              <a:t>6/23/26</a:t>
             </a:fld>
             <a:endParaRPr lang="en-US"/>
           </a:p>
@@ -1793,7 +1793,7 @@
           <a:p>
             <a:fld id="{5BCAD085-E8A6-8845-BD4E-CB4CCA059FC4}" type="datetimeFigureOut">
               <a:rPr lang="en-US" smtClean="0"/>
-              <a:t>6/22/26</a:t>
+              <a:t>6/23/26</a:t>
             </a:fld>
             <a:endParaRPr lang="en-US"/>
           </a:p>
@@ -2212,7 +2212,7 @@
           <a:p>
             <a:fld id="{5BCAD085-E8A6-8845-BD4E-CB4CCA059FC4}" type="datetimeFigureOut">
               <a:rPr lang="en-US" smtClean="0"/>
-              <a:t>6/22/26</a:t>
+              <a:t>6/23/26</a:t>
             </a:fld>
             <a:endParaRPr lang="en-US"/>
           </a:p>
@@ -2329,7 +2329,7 @@
           <a:p>
             <a:fld id="{5BCAD085-E8A6-8845-BD4E-CB4CCA059FC4}" type="datetimeFigureOut">
               <a:rPr lang="en-US" smtClean="0"/>
-              <a:t>6/22/26</a:t>
+              <a:t>6/23/26</a:t>
             </a:fld>
             <a:endParaRPr lang="en-US"/>
           </a:p>
@@ -2424,7 +2424,7 @@
           <a:p>
             <a:fld id="{5BCAD085-E8A6-8845-BD4E-CB4CCA059FC4}" type="datetimeFigureOut">
               <a:rPr lang="en-US" smtClean="0"/>
-              <a:t>6/22/26</a:t>
+              <a:t>6/23/26</a:t>
             </a:fld>
             <a:endParaRPr lang="en-US"/>
           </a:p>
@@ -2699,7 +2699,7 @@
           <a:p>
             <a:fld id="{5BCAD085-E8A6-8845-BD4E-CB4CCA059FC4}" type="datetimeFigureOut">
               <a:rPr lang="en-US" smtClean="0"/>
-              <a:t>6/22/26</a:t>
+              <a:t>6/23/26</a:t>
             </a:fld>
             <a:endParaRPr lang="en-US"/>
           </a:p>
@@ -2951,7 +2951,7 @@
           <a:p>
             <a:fld id="{5BCAD085-E8A6-8845-BD4E-CB4CCA059FC4}" type="datetimeFigureOut">
               <a:rPr lang="en-US" smtClean="0"/>
-              <a:t>6/22/26</a:t>
+              <a:t>6/23/26</a:t>
             </a:fld>
             <a:endParaRPr lang="en-US"/>
           </a:p>
@@ -3162,7 +3162,7 @@
           <a:p>
             <a:fld id="{5BCAD085-E8A6-8845-BD4E-CB4CCA059FC4}" type="datetimeFigureOut">
               <a:rPr lang="en-US" smtClean="0"/>
-              <a:t>6/22/26</a:t>
+              <a:t>6/23/26</a:t>
             </a:fld>
             <a:endParaRPr lang="en-US"/>
           </a:p>
@@ -4125,8 +4125,7 @@
               </a:defRPr>
             </a:pPr>
             <a:r>
-              <a:rPr lang="en-US" sz="1400" dirty="0"/>
-              <a:t>      - Live turn-by-turn mobile app sync. Deploy towing fleet size 	matching.</a:t>
+              <a:t>      - Live turn-by-turn mobile app sync. Deploy towing fleet size matching.</a:t>
             </a:r>
           </a:p>
           <a:p>
@@ -6271,7 +6270,7 @@
             </a:r>
             <a:r>
               <a:rPr sz="1600" dirty="0"/>
-              <a:t>Generates exact TSP shortest tours snapped to road networks in &lt;1ms.</a:t>
+              <a:t>Generates exact TSP shortest tours snapped to road networks in &lt;1ms, with live GPS turn-by-turn navigation.</a:t>
             </a:r>
           </a:p>
           <a:p>
@@ -7277,7 +7276,7 @@
         </p:blipFill>
         <p:spPr>
           <a:xfrm>
-            <a:off x="0" y="0"/>
+            <a:off x="0" y="10510"/>
             <a:ext cx="12286593" cy="6911209"/>
           </a:xfrm>
           <a:prstGeom prst="rect">
@@ -7576,7 +7575,7 @@
         <p:spPr>
           <a:xfrm>
             <a:off x="6583680" y="1920240"/>
-            <a:ext cx="4572000" cy="2846933"/>
+            <a:ext cx="4572000" cy="3093154"/>
           </a:xfrm>
           <a:prstGeom prst="rect">
             <a:avLst/>
@@ -7742,20 +7741,7 @@
               </a:defRPr>
             </a:pPr>
             <a:r>
-              <a:rPr sz="1600" dirty="0"/>
-              <a:t>• </a:t>
-            </a:r>
-            <a:r>
-              <a:rPr sz="1600" b="1" u="sng" dirty="0"/>
-              <a:t>Phase 3: </a:t>
-            </a:r>
-            <a:r>
-              <a:rPr sz="1600" dirty="0"/>
-              <a:t>Exact TSP &amp; Road-Snapping Dispatch</a:t>
-            </a:r>
-            <a:r>
-              <a:rPr lang="en-US" sz="1600" dirty="0"/>
-              <a:t>	</a:t>
+              <a:t>• Phase 3: Exact TSP &amp; Road-Snapping Dispatch</a:t>
             </a:r>
           </a:p>
           <a:p>
@@ -7898,7 +7884,7 @@
           <p:nvPr>
             <p:extLst>
               <p:ext uri="{D42A27DB-BD31-4B8C-83A1-F6EECF244321}">
-                <p14:modId xmlns:p14="http://schemas.microsoft.com/office/powerpoint/2010/main" val="463449312"/>
+                <p14:modId xmlns:p14="http://schemas.microsoft.com/office/powerpoint/2010/main" val="1956330984"/>
               </p:ext>
             </p:extLst>
           </p:nvPr>
@@ -8161,6 +8147,7 @@
                         </a:defRPr>
                       </a:pPr>
                       <a:r>
+                        <a:rPr dirty="0"/>
                         <a:t>Zero-dependency, high-speed API server executing path optimization routing and spatial grid calculations.</a:t>
                       </a:r>
                     </a:p>
@@ -8776,12 +8763,7 @@
               </a:defRPr>
             </a:pPr>
             <a:r>
-              <a:rPr sz="1300" dirty="0"/>
-              <a:t>• </a:t>
-            </a:r>
-            <a:r>
-              <a:rPr sz="1300" b="1" u="sng" dirty="0"/>
-              <a:t>Exact TSP Shortest Tour Pathfinder (OSRM Road-Snapping):</a:t>
+              <a:t>• Exact TSP Shortest Tour Pathfinder (OSRM Road-Snapping):</a:t>
             </a:r>
           </a:p>
           <a:p>
@@ -8797,20 +8779,7 @@
               </a:defRPr>
             </a:pPr>
             <a:r>
-              <a:rPr lang="en-US" sz="1300" dirty="0"/>
-              <a:t>    </a:t>
-            </a:r>
-            <a:r>
-              <a:rPr sz="1300" dirty="0"/>
-              <a:t> - Solves Traveling Salesperson Problem (TSP) exactly to find the </a:t>
-            </a:r>
-            <a:r>
-              <a:rPr lang="en-US" sz="1300" dirty="0"/>
-              <a:t>	</a:t>
-            </a:r>
-            <a:r>
-              <a:rPr sz="1300" dirty="0"/>
-              <a:t>absolute shortest round tour.</a:t>
+              <a:t>     - Solves Traveling Salesperson Problem (TSP) exactly to find the absolute shortest round tour.</a:t>
             </a:r>
           </a:p>
           <a:p>
@@ -8826,20 +8795,7 @@
               </a:defRPr>
             </a:pPr>
             <a:r>
-              <a:rPr lang="en-US" sz="1300" dirty="0"/>
-              <a:t>    </a:t>
-            </a:r>
-            <a:r>
-              <a:rPr sz="1300" dirty="0"/>
-              <a:t>- Snaps path to live road geometry via OSRM, including real turn-</a:t>
-            </a:r>
-            <a:r>
-              <a:rPr lang="en-US" sz="1300" dirty="0"/>
-              <a:t>	</a:t>
-            </a:r>
-            <a:r>
-              <a:rPr sz="1300" dirty="0"/>
-              <a:t>by-turn navigation.</a:t>
+              <a:t>    - Snaps path to live road geometry via OSRM, including real turn-by-turn navigation.</a:t>
             </a:r>
           </a:p>
           <a:p>
@@ -9950,6 +9906,7 @@
               </a:defRPr>
             </a:pPr>
             <a:r>
+              <a:rPr dirty="0"/>
               <a:t>5. Dispatch warden</a:t>
             </a:r>
           </a:p>

</xml_diff>

<commit_message>
Revert all modifications to Flikart_Grid_Lock_hackathon_Round_2_Confluent.pptx
</commit_message>
<xml_diff>
--- a/Flikart_Grid_Lock_hackathon_Round_2_Confluent.pptx
+++ b/Flikart_Grid_Lock_hackathon_Round_2_Confluent.pptx
@@ -4,9 +4,6 @@
   <p:sldMasterIdLst>
     <p:sldMasterId id="2147483648" r:id="rId1"/>
   </p:sldMasterIdLst>
-  <p:notesMasterIdLst>
-    <p:notesMasterId r:id="rId14"/>
-  </p:notesMasterIdLst>
   <p:sldIdLst>
     <p:sldId id="256" r:id="rId2"/>
     <p:sldId id="265" r:id="rId3"/>
@@ -137,439 +134,6 @@
 </p:presentation>
 </file>
 
-<file path=ppt/notesMasters/notesMaster1.xml><?xml version="1.0" encoding="utf-8"?>
-<p:notesMaster xmlns:a="http://schemas.openxmlformats.org/drawingml/2006/main" xmlns:r="http://schemas.openxmlformats.org/officeDocument/2006/relationships" xmlns:p="http://schemas.openxmlformats.org/presentationml/2006/main">
-  <p:cSld>
-    <p:bg>
-      <p:bgRef idx="1001">
-        <a:schemeClr val="bg1"/>
-      </p:bgRef>
-    </p:bg>
-    <p:spTree>
-      <p:nvGrpSpPr>
-        <p:cNvPr id="1" name=""/>
-        <p:cNvGrpSpPr/>
-        <p:nvPr/>
-      </p:nvGrpSpPr>
-      <p:grpSpPr>
-        <a:xfrm>
-          <a:off x="0" y="0"/>
-          <a:ext cx="0" cy="0"/>
-          <a:chOff x="0" y="0"/>
-          <a:chExt cx="0" cy="0"/>
-        </a:xfrm>
-      </p:grpSpPr>
-      <p:sp>
-        <p:nvSpPr>
-          <p:cNvPr id="2" name="Header Placeholder 1"/>
-          <p:cNvSpPr>
-            <a:spLocks noGrp="1"/>
-          </p:cNvSpPr>
-          <p:nvPr>
-            <p:ph type="hdr" sz="quarter"/>
-          </p:nvPr>
-        </p:nvSpPr>
-        <p:spPr>
-          <a:xfrm>
-            <a:off x="0" y="0"/>
-            <a:ext cx="2971800" cy="458788"/>
-          </a:xfrm>
-          <a:prstGeom prst="rect">
-            <a:avLst/>
-          </a:prstGeom>
-        </p:spPr>
-        <p:txBody>
-          <a:bodyPr vert="horz" lIns="91440" tIns="45720" rIns="91440" bIns="45720" rtlCol="0"/>
-          <a:lstStyle>
-            <a:lvl1pPr algn="l">
-              <a:defRPr sz="1200"/>
-            </a:lvl1pPr>
-          </a:lstStyle>
-          <a:p>
-            <a:endParaRPr lang="en-US"/>
-          </a:p>
-        </p:txBody>
-      </p:sp>
-      <p:sp>
-        <p:nvSpPr>
-          <p:cNvPr id="3" name="Date Placeholder 2"/>
-          <p:cNvSpPr>
-            <a:spLocks noGrp="1"/>
-          </p:cNvSpPr>
-          <p:nvPr>
-            <p:ph type="dt" idx="1"/>
-          </p:nvPr>
-        </p:nvSpPr>
-        <p:spPr>
-          <a:xfrm>
-            <a:off x="3884613" y="0"/>
-            <a:ext cx="2971800" cy="458788"/>
-          </a:xfrm>
-          <a:prstGeom prst="rect">
-            <a:avLst/>
-          </a:prstGeom>
-        </p:spPr>
-        <p:txBody>
-          <a:bodyPr vert="horz" lIns="91440" tIns="45720" rIns="91440" bIns="45720" rtlCol="0"/>
-          <a:lstStyle>
-            <a:lvl1pPr algn="r">
-              <a:defRPr sz="1200"/>
-            </a:lvl1pPr>
-          </a:lstStyle>
-          <a:p>
-            <a:fld id="{5C8CBD25-6209-B341-A3EB-3CFC2FF39C7A}" type="datetimeFigureOut">
-              <a:rPr lang="en-US" smtClean="0"/>
-              <a:t>6/23/26</a:t>
-            </a:fld>
-            <a:endParaRPr lang="en-US"/>
-          </a:p>
-        </p:txBody>
-      </p:sp>
-      <p:sp>
-        <p:nvSpPr>
-          <p:cNvPr id="4" name="Slide Image Placeholder 3"/>
-          <p:cNvSpPr>
-            <a:spLocks noGrp="1" noRot="1" noChangeAspect="1"/>
-          </p:cNvSpPr>
-          <p:nvPr>
-            <p:ph type="sldImg" idx="2"/>
-          </p:nvPr>
-        </p:nvSpPr>
-        <p:spPr>
-          <a:xfrm>
-            <a:off x="685800" y="1143000"/>
-            <a:ext cx="5486400" cy="3086100"/>
-          </a:xfrm>
-          <a:prstGeom prst="rect">
-            <a:avLst/>
-          </a:prstGeom>
-          <a:noFill/>
-          <a:ln w="12700">
-            <a:solidFill>
-              <a:prstClr val="black"/>
-            </a:solidFill>
-          </a:ln>
-        </p:spPr>
-        <p:txBody>
-          <a:bodyPr vert="horz" lIns="91440" tIns="45720" rIns="91440" bIns="45720" rtlCol="0" anchor="ctr"/>
-          <a:lstStyle/>
-          <a:p>
-            <a:endParaRPr lang="en-US"/>
-          </a:p>
-        </p:txBody>
-      </p:sp>
-      <p:sp>
-        <p:nvSpPr>
-          <p:cNvPr id="5" name="Notes Placeholder 4"/>
-          <p:cNvSpPr>
-            <a:spLocks noGrp="1"/>
-          </p:cNvSpPr>
-          <p:nvPr>
-            <p:ph type="body" sz="quarter" idx="3"/>
-          </p:nvPr>
-        </p:nvSpPr>
-        <p:spPr>
-          <a:xfrm>
-            <a:off x="685800" y="4400550"/>
-            <a:ext cx="5486400" cy="3600450"/>
-          </a:xfrm>
-          <a:prstGeom prst="rect">
-            <a:avLst/>
-          </a:prstGeom>
-        </p:spPr>
-        <p:txBody>
-          <a:bodyPr vert="horz" lIns="91440" tIns="45720" rIns="91440" bIns="45720" rtlCol="0"/>
-          <a:lstStyle/>
-          <a:p>
-            <a:pPr lvl="0"/>
-            <a:r>
-              <a:rPr lang="en-US"/>
-              <a:t>Edit Master text styles</a:t>
-            </a:r>
-          </a:p>
-          <a:p>
-            <a:pPr lvl="1"/>
-            <a:r>
-              <a:rPr lang="en-US"/>
-              <a:t>Second level</a:t>
-            </a:r>
-          </a:p>
-          <a:p>
-            <a:pPr lvl="2"/>
-            <a:r>
-              <a:rPr lang="en-US"/>
-              <a:t>Third level</a:t>
-            </a:r>
-          </a:p>
-          <a:p>
-            <a:pPr lvl="3"/>
-            <a:r>
-              <a:rPr lang="en-US"/>
-              <a:t>Fourth level</a:t>
-            </a:r>
-          </a:p>
-          <a:p>
-            <a:pPr lvl="4"/>
-            <a:r>
-              <a:rPr lang="en-US"/>
-              <a:t>Fifth level</a:t>
-            </a:r>
-          </a:p>
-        </p:txBody>
-      </p:sp>
-      <p:sp>
-        <p:nvSpPr>
-          <p:cNvPr id="6" name="Footer Placeholder 5"/>
-          <p:cNvSpPr>
-            <a:spLocks noGrp="1"/>
-          </p:cNvSpPr>
-          <p:nvPr>
-            <p:ph type="ftr" sz="quarter" idx="4"/>
-          </p:nvPr>
-        </p:nvSpPr>
-        <p:spPr>
-          <a:xfrm>
-            <a:off x="0" y="8685213"/>
-            <a:ext cx="2971800" cy="458787"/>
-          </a:xfrm>
-          <a:prstGeom prst="rect">
-            <a:avLst/>
-          </a:prstGeom>
-        </p:spPr>
-        <p:txBody>
-          <a:bodyPr vert="horz" lIns="91440" tIns="45720" rIns="91440" bIns="45720" rtlCol="0" anchor="b"/>
-          <a:lstStyle>
-            <a:lvl1pPr algn="l">
-              <a:defRPr sz="1200"/>
-            </a:lvl1pPr>
-          </a:lstStyle>
-          <a:p>
-            <a:endParaRPr lang="en-US"/>
-          </a:p>
-        </p:txBody>
-      </p:sp>
-      <p:sp>
-        <p:nvSpPr>
-          <p:cNvPr id="7" name="Slide Number Placeholder 6"/>
-          <p:cNvSpPr>
-            <a:spLocks noGrp="1"/>
-          </p:cNvSpPr>
-          <p:nvPr>
-            <p:ph type="sldNum" sz="quarter" idx="5"/>
-          </p:nvPr>
-        </p:nvSpPr>
-        <p:spPr>
-          <a:xfrm>
-            <a:off x="3884613" y="8685213"/>
-            <a:ext cx="2971800" cy="458787"/>
-          </a:xfrm>
-          <a:prstGeom prst="rect">
-            <a:avLst/>
-          </a:prstGeom>
-        </p:spPr>
-        <p:txBody>
-          <a:bodyPr vert="horz" lIns="91440" tIns="45720" rIns="91440" bIns="45720" rtlCol="0" anchor="b"/>
-          <a:lstStyle>
-            <a:lvl1pPr algn="r">
-              <a:defRPr sz="1200"/>
-            </a:lvl1pPr>
-          </a:lstStyle>
-          <a:p>
-            <a:fld id="{8697A498-47AA-1043-BA67-9567D7B7BA32}" type="slidenum">
-              <a:rPr lang="en-US" smtClean="0"/>
-              <a:t>‹#›</a:t>
-            </a:fld>
-            <a:endParaRPr lang="en-US"/>
-          </a:p>
-        </p:txBody>
-      </p:sp>
-    </p:spTree>
-    <p:extLst>
-      <p:ext uri="{BB962C8B-B14F-4D97-AF65-F5344CB8AC3E}">
-        <p14:creationId xmlns:p14="http://schemas.microsoft.com/office/powerpoint/2010/main" val="1299757266"/>
-      </p:ext>
-    </p:extLst>
-  </p:cSld>
-  <p:clrMap bg1="lt1" tx1="dk1" bg2="lt2" tx2="dk2" accent1="accent1" accent2="accent2" accent3="accent3" accent4="accent4" accent5="accent5" accent6="accent6" hlink="hlink" folHlink="folHlink"/>
-  <p:notesStyle>
-    <a:lvl1pPr marL="0" algn="l" defTabSz="914400" rtl="0" eaLnBrk="1" latinLnBrk="0" hangingPunct="1">
-      <a:defRPr sz="1200" kern="1200">
-        <a:solidFill>
-          <a:schemeClr val="tx1"/>
-        </a:solidFill>
-        <a:latin typeface="+mn-lt"/>
-        <a:ea typeface="+mn-ea"/>
-        <a:cs typeface="+mn-cs"/>
-      </a:defRPr>
-    </a:lvl1pPr>
-    <a:lvl2pPr marL="457200" algn="l" defTabSz="914400" rtl="0" eaLnBrk="1" latinLnBrk="0" hangingPunct="1">
-      <a:defRPr sz="1200" kern="1200">
-        <a:solidFill>
-          <a:schemeClr val="tx1"/>
-        </a:solidFill>
-        <a:latin typeface="+mn-lt"/>
-        <a:ea typeface="+mn-ea"/>
-        <a:cs typeface="+mn-cs"/>
-      </a:defRPr>
-    </a:lvl2pPr>
-    <a:lvl3pPr marL="914400" algn="l" defTabSz="914400" rtl="0" eaLnBrk="1" latinLnBrk="0" hangingPunct="1">
-      <a:defRPr sz="1200" kern="1200">
-        <a:solidFill>
-          <a:schemeClr val="tx1"/>
-        </a:solidFill>
-        <a:latin typeface="+mn-lt"/>
-        <a:ea typeface="+mn-ea"/>
-        <a:cs typeface="+mn-cs"/>
-      </a:defRPr>
-    </a:lvl3pPr>
-    <a:lvl4pPr marL="1371600" algn="l" defTabSz="914400" rtl="0" eaLnBrk="1" latinLnBrk="0" hangingPunct="1">
-      <a:defRPr sz="1200" kern="1200">
-        <a:solidFill>
-          <a:schemeClr val="tx1"/>
-        </a:solidFill>
-        <a:latin typeface="+mn-lt"/>
-        <a:ea typeface="+mn-ea"/>
-        <a:cs typeface="+mn-cs"/>
-      </a:defRPr>
-    </a:lvl4pPr>
-    <a:lvl5pPr marL="1828800" algn="l" defTabSz="914400" rtl="0" eaLnBrk="1" latinLnBrk="0" hangingPunct="1">
-      <a:defRPr sz="1200" kern="1200">
-        <a:solidFill>
-          <a:schemeClr val="tx1"/>
-        </a:solidFill>
-        <a:latin typeface="+mn-lt"/>
-        <a:ea typeface="+mn-ea"/>
-        <a:cs typeface="+mn-cs"/>
-      </a:defRPr>
-    </a:lvl5pPr>
-    <a:lvl6pPr marL="2286000" algn="l" defTabSz="914400" rtl="0" eaLnBrk="1" latinLnBrk="0" hangingPunct="1">
-      <a:defRPr sz="1200" kern="1200">
-        <a:solidFill>
-          <a:schemeClr val="tx1"/>
-        </a:solidFill>
-        <a:latin typeface="+mn-lt"/>
-        <a:ea typeface="+mn-ea"/>
-        <a:cs typeface="+mn-cs"/>
-      </a:defRPr>
-    </a:lvl6pPr>
-    <a:lvl7pPr marL="2743200" algn="l" defTabSz="914400" rtl="0" eaLnBrk="1" latinLnBrk="0" hangingPunct="1">
-      <a:defRPr sz="1200" kern="1200">
-        <a:solidFill>
-          <a:schemeClr val="tx1"/>
-        </a:solidFill>
-        <a:latin typeface="+mn-lt"/>
-        <a:ea typeface="+mn-ea"/>
-        <a:cs typeface="+mn-cs"/>
-      </a:defRPr>
-    </a:lvl7pPr>
-    <a:lvl8pPr marL="3200400" algn="l" defTabSz="914400" rtl="0" eaLnBrk="1" latinLnBrk="0" hangingPunct="1">
-      <a:defRPr sz="1200" kern="1200">
-        <a:solidFill>
-          <a:schemeClr val="tx1"/>
-        </a:solidFill>
-        <a:latin typeface="+mn-lt"/>
-        <a:ea typeface="+mn-ea"/>
-        <a:cs typeface="+mn-cs"/>
-      </a:defRPr>
-    </a:lvl8pPr>
-    <a:lvl9pPr marL="3657600" algn="l" defTabSz="914400" rtl="0" eaLnBrk="1" latinLnBrk="0" hangingPunct="1">
-      <a:defRPr sz="1200" kern="1200">
-        <a:solidFill>
-          <a:schemeClr val="tx1"/>
-        </a:solidFill>
-        <a:latin typeface="+mn-lt"/>
-        <a:ea typeface="+mn-ea"/>
-        <a:cs typeface="+mn-cs"/>
-      </a:defRPr>
-    </a:lvl9pPr>
-  </p:notesStyle>
-</p:notesMaster>
-</file>
-
-<file path=ppt/notesSlides/notesSlide1.xml><?xml version="1.0" encoding="utf-8"?>
-<p:notes xmlns:a="http://schemas.openxmlformats.org/drawingml/2006/main" xmlns:r="http://schemas.openxmlformats.org/officeDocument/2006/relationships" xmlns:p="http://schemas.openxmlformats.org/presentationml/2006/main">
-  <p:cSld>
-    <p:spTree>
-      <p:nvGrpSpPr>
-        <p:cNvPr id="1" name=""/>
-        <p:cNvGrpSpPr/>
-        <p:nvPr/>
-      </p:nvGrpSpPr>
-      <p:grpSpPr>
-        <a:xfrm>
-          <a:off x="0" y="0"/>
-          <a:ext cx="0" cy="0"/>
-          <a:chOff x="0" y="0"/>
-          <a:chExt cx="0" cy="0"/>
-        </a:xfrm>
-      </p:grpSpPr>
-      <p:sp>
-        <p:nvSpPr>
-          <p:cNvPr id="2" name="Slide Image Placeholder 1"/>
-          <p:cNvSpPr>
-            <a:spLocks noGrp="1" noRot="1" noChangeAspect="1"/>
-          </p:cNvSpPr>
-          <p:nvPr>
-            <p:ph type="sldImg"/>
-          </p:nvPr>
-        </p:nvSpPr>
-        <p:spPr/>
-      </p:sp>
-      <p:sp>
-        <p:nvSpPr>
-          <p:cNvPr id="3" name="Notes Placeholder 2"/>
-          <p:cNvSpPr>
-            <a:spLocks noGrp="1"/>
-          </p:cNvSpPr>
-          <p:nvPr>
-            <p:ph type="body" idx="1"/>
-          </p:nvPr>
-        </p:nvSpPr>
-        <p:spPr/>
-        <p:txBody>
-          <a:bodyPr/>
-          <a:lstStyle/>
-          <a:p>
-            <a:endParaRPr lang="en-US" dirty="0"/>
-          </a:p>
-        </p:txBody>
-      </p:sp>
-      <p:sp>
-        <p:nvSpPr>
-          <p:cNvPr id="4" name="Slide Number Placeholder 3"/>
-          <p:cNvSpPr>
-            <a:spLocks noGrp="1"/>
-          </p:cNvSpPr>
-          <p:nvPr>
-            <p:ph type="sldNum" sz="quarter" idx="10"/>
-          </p:nvPr>
-        </p:nvSpPr>
-        <p:spPr/>
-        <p:txBody>
-          <a:bodyPr/>
-          <a:lstStyle/>
-          <a:p>
-            <a:fld id="{8697A498-47AA-1043-BA67-9567D7B7BA32}" type="slidenum">
-              <a:rPr lang="en-US" smtClean="0"/>
-              <a:t>11</a:t>
-            </a:fld>
-            <a:endParaRPr lang="en-US"/>
-          </a:p>
-        </p:txBody>
-      </p:sp>
-    </p:spTree>
-    <p:extLst>
-      <p:ext uri="{BB962C8B-B14F-4D97-AF65-F5344CB8AC3E}">
-        <p14:creationId xmlns:p14="http://schemas.microsoft.com/office/powerpoint/2010/main" val="2893114229"/>
-      </p:ext>
-    </p:extLst>
-  </p:cSld>
-  <p:clrMapOvr>
-    <a:masterClrMapping/>
-  </p:clrMapOvr>
-</p:notes>
-</file>
-
 <file path=ppt/slideLayouts/slideLayout1.xml><?xml version="1.0" encoding="utf-8"?>
 <p:sldLayout xmlns:a="http://schemas.openxmlformats.org/drawingml/2006/main" xmlns:r="http://schemas.openxmlformats.org/officeDocument/2006/relationships" xmlns:p="http://schemas.openxmlformats.org/presentationml/2006/main" type="title" preserve="1">
   <p:cSld name="Title Slide">
@@ -749,7 +313,7 @@
           <a:p>
             <a:fld id="{5BCAD085-E8A6-8845-BD4E-CB4CCA059FC4}" type="datetimeFigureOut">
               <a:rPr lang="en-US" smtClean="0"/>
-              <a:t>6/23/26</a:t>
+              <a:t>6/21/26</a:t>
             </a:fld>
             <a:endParaRPr lang="en-US"/>
           </a:p>
@@ -917,7 +481,7 @@
           <a:p>
             <a:fld id="{5BCAD085-E8A6-8845-BD4E-CB4CCA059FC4}" type="datetimeFigureOut">
               <a:rPr lang="en-US" smtClean="0"/>
-              <a:t>6/23/26</a:t>
+              <a:t>6/21/26</a:t>
             </a:fld>
             <a:endParaRPr lang="en-US"/>
           </a:p>
@@ -1095,7 +659,7 @@
           <a:p>
             <a:fld id="{5BCAD085-E8A6-8845-BD4E-CB4CCA059FC4}" type="datetimeFigureOut">
               <a:rPr lang="en-US" smtClean="0"/>
-              <a:t>6/23/26</a:t>
+              <a:t>6/21/26</a:t>
             </a:fld>
             <a:endParaRPr lang="en-US"/>
           </a:p>
@@ -1263,7 +827,7 @@
           <a:p>
             <a:fld id="{5BCAD085-E8A6-8845-BD4E-CB4CCA059FC4}" type="datetimeFigureOut">
               <a:rPr lang="en-US" smtClean="0"/>
-              <a:t>6/23/26</a:t>
+              <a:t>6/21/26</a:t>
             </a:fld>
             <a:endParaRPr lang="en-US"/>
           </a:p>
@@ -1508,7 +1072,7 @@
           <a:p>
             <a:fld id="{5BCAD085-E8A6-8845-BD4E-CB4CCA059FC4}" type="datetimeFigureOut">
               <a:rPr lang="en-US" smtClean="0"/>
-              <a:t>6/23/26</a:t>
+              <a:t>6/21/26</a:t>
             </a:fld>
             <a:endParaRPr lang="en-US"/>
           </a:p>
@@ -1793,7 +1357,7 @@
           <a:p>
             <a:fld id="{5BCAD085-E8A6-8845-BD4E-CB4CCA059FC4}" type="datetimeFigureOut">
               <a:rPr lang="en-US" smtClean="0"/>
-              <a:t>6/23/26</a:t>
+              <a:t>6/21/26</a:t>
             </a:fld>
             <a:endParaRPr lang="en-US"/>
           </a:p>
@@ -2212,7 +1776,7 @@
           <a:p>
             <a:fld id="{5BCAD085-E8A6-8845-BD4E-CB4CCA059FC4}" type="datetimeFigureOut">
               <a:rPr lang="en-US" smtClean="0"/>
-              <a:t>6/23/26</a:t>
+              <a:t>6/21/26</a:t>
             </a:fld>
             <a:endParaRPr lang="en-US"/>
           </a:p>
@@ -2329,7 +1893,7 @@
           <a:p>
             <a:fld id="{5BCAD085-E8A6-8845-BD4E-CB4CCA059FC4}" type="datetimeFigureOut">
               <a:rPr lang="en-US" smtClean="0"/>
-              <a:t>6/23/26</a:t>
+              <a:t>6/21/26</a:t>
             </a:fld>
             <a:endParaRPr lang="en-US"/>
           </a:p>
@@ -2424,7 +1988,7 @@
           <a:p>
             <a:fld id="{5BCAD085-E8A6-8845-BD4E-CB4CCA059FC4}" type="datetimeFigureOut">
               <a:rPr lang="en-US" smtClean="0"/>
-              <a:t>6/23/26</a:t>
+              <a:t>6/21/26</a:t>
             </a:fld>
             <a:endParaRPr lang="en-US"/>
           </a:p>
@@ -2699,7 +2263,7 @@
           <a:p>
             <a:fld id="{5BCAD085-E8A6-8845-BD4E-CB4CCA059FC4}" type="datetimeFigureOut">
               <a:rPr lang="en-US" smtClean="0"/>
-              <a:t>6/23/26</a:t>
+              <a:t>6/21/26</a:t>
             </a:fld>
             <a:endParaRPr lang="en-US"/>
           </a:p>
@@ -2951,7 +2515,7 @@
           <a:p>
             <a:fld id="{5BCAD085-E8A6-8845-BD4E-CB4CCA059FC4}" type="datetimeFigureOut">
               <a:rPr lang="en-US" smtClean="0"/>
-              <a:t>6/23/26</a:t>
+              <a:t>6/21/26</a:t>
             </a:fld>
             <a:endParaRPr lang="en-US"/>
           </a:p>
@@ -3162,7 +2726,7 @@
           <a:p>
             <a:fld id="{5BCAD085-E8A6-8845-BD4E-CB4CCA059FC4}" type="datetimeFigureOut">
               <a:rPr lang="en-US" smtClean="0"/>
-              <a:t>6/23/26</a:t>
+              <a:t>6/21/26</a:t>
             </a:fld>
             <a:endParaRPr lang="en-US"/>
           </a:p>
@@ -3982,7 +3546,7 @@
         <p:spPr>
           <a:xfrm>
             <a:off x="6583680" y="1920240"/>
-            <a:ext cx="4572000" cy="3339376"/>
+            <a:ext cx="4572000" cy="3123932"/>
           </a:xfrm>
           <a:prstGeom prst="rect">
             <a:avLst/>
@@ -4125,7 +3689,8 @@
               </a:defRPr>
             </a:pPr>
             <a:r>
-              <a:t>      - Live turn-by-turn mobile app sync. Deploy towing fleet size matching.</a:t>
+              <a:rPr lang="en-US" sz="1400" dirty="0"/>
+              <a:t>      - Warden navigation app. Deploy towing fleet size matching.</a:t>
             </a:r>
           </a:p>
           <a:p>
@@ -4279,7 +3844,7 @@
           <p:nvPr/>
         </p:nvPicPr>
         <p:blipFill>
-          <a:blip r:embed="rId3"/>
+          <a:blip r:embed="rId2"/>
           <a:stretch>
             <a:fillRect/>
           </a:stretch>
@@ -4712,7 +4277,7 @@
                     <a:lumOff val="5000"/>
                   </a:schemeClr>
                 </a:solidFill>
-                <a:hlinkClick r:id="rId4"/>
+                <a:hlinkClick r:id="rId3"/>
               </a:rPr>
               <a:t>https://sb01022006.github.io/ai-parking-congestion-intelligence/</a:t>
             </a:r>
@@ -4756,7 +4321,7 @@
                     <a:lumOff val="5000"/>
                   </a:schemeClr>
                 </a:solidFill>
-                <a:hlinkClick r:id="rId5"/>
+                <a:hlinkClick r:id="rId4"/>
               </a:rPr>
               <a:t>https://ai-parking-congestion-intelligence.onrender.com</a:t>
             </a:r>
@@ -4800,7 +4365,7 @@
                     <a:lumOff val="5000"/>
                   </a:schemeClr>
                 </a:solidFill>
-                <a:hlinkClick r:id="rId6"/>
+                <a:hlinkClick r:id="rId5"/>
               </a:rPr>
               <a:t>https://github.com/sb01022006/ai-parking-congestion-intelligence</a:t>
             </a:r>
@@ -4844,7 +4409,7 @@
                     <a:lumOff val="5000"/>
                   </a:schemeClr>
                 </a:solidFill>
-                <a:hlinkClick r:id="rId7"/>
+                <a:hlinkClick r:id="rId6"/>
               </a:rPr>
               <a:t>https://drive.google.com/file/d/1BrF4HMsvkTWnxRqcdl6Lb8lGopAEfH8V/view</a:t>
             </a:r>
@@ -6169,7 +5734,7 @@
         <p:spPr>
           <a:xfrm>
             <a:off x="6583680" y="1920240"/>
-            <a:ext cx="4572000" cy="3236784"/>
+            <a:ext cx="4572000" cy="3483005"/>
           </a:xfrm>
           <a:prstGeom prst="rect">
             <a:avLst/>
@@ -6261,16 +5826,12 @@
               </a:defRPr>
             </a:pPr>
             <a:r>
-              <a:rPr sz="1600" b="1" dirty="0"/>
-              <a:t>•</a:t>
-            </a:r>
-            <a:r>
               <a:rPr sz="1600" b="1" u="sng" dirty="0"/>
-              <a:t> AI Patrol Route Pathfinder: </a:t>
+              <a:t>• AI Patrol Route Pathfinder: </a:t>
             </a:r>
             <a:r>
               <a:rPr sz="1600" dirty="0"/>
-              <a:t>Generates exact TSP shortest tours snapped to road networks in &lt;1ms, with live GPS turn-by-turn navigation.</a:t>
+              <a:t>Generates optimized nearest-neighbor officer routing paths on the map in &lt;1ms.</a:t>
             </a:r>
           </a:p>
           <a:p>
@@ -6613,8 +6174,8 @@
               <a:t>Enforcement is reactive; no </a:t>
             </a:r>
             <a:r>
-              <a:rPr lang="en-US" sz="1600" dirty="0"/>
-              <a:t>heat map</a:t>
+              <a:rPr sz="1600" dirty="0" err="1"/>
+              <a:t>heatmap</a:t>
             </a:r>
             <a:r>
               <a:rPr sz="1600" dirty="0"/>
@@ -7276,7 +6837,7 @@
         </p:blipFill>
         <p:spPr>
           <a:xfrm>
-            <a:off x="0" y="10510"/>
+            <a:off x="0" y="0"/>
             <a:ext cx="12286593" cy="6911209"/>
           </a:xfrm>
           <a:prstGeom prst="rect">
@@ -7496,15 +7057,15 @@
               <a:t>• </a:t>
             </a:r>
             <a:r>
-              <a:rPr sz="1600" b="1" dirty="0"/>
+              <a:rPr sz="1600" b="1" u="sng" dirty="0"/>
               <a:t>We propose </a:t>
             </a:r>
             <a:r>
-              <a:rPr sz="1600" b="1" dirty="0" err="1"/>
+              <a:rPr sz="1600" b="1" u="sng" dirty="0" err="1"/>
               <a:t>VeloCity</a:t>
             </a:r>
             <a:r>
-              <a:rPr sz="1600" b="1" dirty="0"/>
+              <a:rPr sz="1600" b="1" u="sng" dirty="0"/>
               <a:t>: </a:t>
             </a:r>
             <a:r>
@@ -7527,10 +7088,6 @@
             <a:r>
               <a:rPr sz="1600" dirty="0"/>
               <a:t>• Rather than scheduling uniform warden patrols, </a:t>
-            </a:r>
-            <a:r>
-              <a:rPr lang="en-US" sz="1600" dirty="0"/>
-              <a:t>  </a:t>
             </a:r>
             <a:r>
               <a:rPr sz="1600" dirty="0" err="1"/>
@@ -7575,7 +7132,7 @@
         <p:spPr>
           <a:xfrm>
             <a:off x="6583680" y="1920240"/>
-            <a:ext cx="4572000" cy="3093154"/>
+            <a:ext cx="4572000" cy="2846933"/>
           </a:xfrm>
           <a:prstGeom prst="rect">
             <a:avLst/>
@@ -7655,19 +7212,11 @@
             </a:r>
             <a:r>
               <a:rPr sz="1600" dirty="0"/>
-              <a:t>- Cleans 298,450 records, converting UTC to IST to </a:t>
+              <a:t>- Cleans 298,450 records, converting UTC to IST to map daytime </a:t>
             </a:r>
             <a:r>
               <a:rPr lang="en-US" sz="1600" dirty="0"/>
-              <a:t>	   </a:t>
-            </a:r>
-            <a:r>
-              <a:rPr sz="1600" dirty="0"/>
-              <a:t>map daytime</a:t>
-            </a:r>
-            <a:r>
-              <a:rPr lang="en-US" sz="1600" dirty="0"/>
-              <a:t> </a:t>
+              <a:t>	</a:t>
             </a:r>
             <a:r>
               <a:rPr sz="1600" dirty="0"/>
@@ -7717,15 +7266,15 @@
             </a:r>
             <a:r>
               <a:rPr sz="1600" dirty="0"/>
-              <a:t>- Computes localized grids severity dynamically </a:t>
+              <a:t>- Computes localized grids severity dynamically using dispatcher </a:t>
             </a:r>
             <a:r>
               <a:rPr lang="en-US" sz="1600" dirty="0"/>
-              <a:t>	  	   </a:t>
+              <a:t>	</a:t>
             </a:r>
             <a:r>
               <a:rPr sz="1600" dirty="0"/>
-              <a:t>using dispatcher sliders.</a:t>
+              <a:t>sliders.</a:t>
             </a:r>
           </a:p>
           <a:p>
@@ -7741,7 +7290,20 @@
               </a:defRPr>
             </a:pPr>
             <a:r>
-              <a:t>• Phase 3: Exact TSP &amp; Road-Snapping Dispatch</a:t>
+              <a:rPr sz="1600" dirty="0"/>
+              <a:t>• </a:t>
+            </a:r>
+            <a:r>
+              <a:rPr sz="1600" b="1" u="sng" dirty="0"/>
+              <a:t>Phase 3: </a:t>
+            </a:r>
+            <a:r>
+              <a:rPr sz="1600" dirty="0"/>
+              <a:t>Greedy Pathfinder Dispatch</a:t>
+            </a:r>
+            <a:r>
+              <a:rPr lang="en-US" sz="1600" dirty="0"/>
+              <a:t>	</a:t>
             </a:r>
           </a:p>
           <a:p>
@@ -7757,7 +7319,20 @@
               </a:defRPr>
             </a:pPr>
             <a:r>
-              <a:t>	- Solves Exact TSP tour in &lt;1ms, snaps routes to roads using OSRM, and generates GPS turn-by-turn navigation for wardens.</a:t>
+              <a:rPr lang="en-US" sz="1600" dirty="0"/>
+              <a:t>	</a:t>
+            </a:r>
+            <a:r>
+              <a:rPr sz="1600" dirty="0"/>
+              <a:t>- Executes nearest-neighbor routing algorithms in </a:t>
+            </a:r>
+            <a:r>
+              <a:rPr lang="en-US" sz="1600" dirty="0"/>
+              <a:t>	</a:t>
+            </a:r>
+            <a:r>
+              <a:rPr sz="1600" dirty="0"/>
+              <a:t>&lt;1ms to dispatch wardens.</a:t>
             </a:r>
           </a:p>
         </p:txBody>
@@ -7884,7 +7459,7 @@
           <p:nvPr>
             <p:extLst>
               <p:ext uri="{D42A27DB-BD31-4B8C-83A1-F6EECF244321}">
-                <p14:modId xmlns:p14="http://schemas.microsoft.com/office/powerpoint/2010/main" val="1956330984"/>
+                <p14:modId xmlns:p14="http://schemas.microsoft.com/office/powerpoint/2010/main" val="463449312"/>
               </p:ext>
             </p:extLst>
           </p:nvPr>
@@ -8066,8 +7641,16 @@
                     <a:bodyPr/>
                     <a:lstStyle/>
                     <a:p>
+                      <a:pPr algn="ctr">
+                        <a:defRPr sz="1300" b="0">
+                          <a:solidFill>
+                            <a:srgbClr val="0F172A"/>
+                          </a:solidFill>
+                          <a:latin typeface="Calibri"/>
+                        </a:defRPr>
+                      </a:pPr>
                       <a:r>
-                        <a:t>Provides a fast, component-based mapping UI with custom Leaflet markers, snapped routes, and a live GPS turn-by-turn navigation panel.</a:t>
+                        <a:t>Provides a fast, component-based mapping UI with custom Leaflet markers, polyline routes, and slider panels.</a:t>
                       </a:r>
                     </a:p>
                   </a:txBody>
@@ -8147,7 +7730,6 @@
                         </a:defRPr>
                       </a:pPr>
                       <a:r>
-                        <a:rPr dirty="0"/>
                         <a:t>Zero-dependency, high-speed API server executing path optimization routing and spatial grid calculations.</a:t>
                       </a:r>
                     </a:p>
@@ -8563,7 +8145,7 @@
         <p:spPr>
           <a:xfrm>
             <a:off x="1005840" y="1920240"/>
-            <a:ext cx="4572000" cy="3893374"/>
+            <a:ext cx="4572000" cy="3693319"/>
           </a:xfrm>
           <a:prstGeom prst="rect">
             <a:avLst/>
@@ -8763,7 +8345,12 @@
               </a:defRPr>
             </a:pPr>
             <a:r>
-              <a:t>• Exact TSP Shortest Tour Pathfinder (OSRM Road-Snapping):</a:t>
+              <a:rPr sz="1300" dirty="0"/>
+              <a:t>• </a:t>
+            </a:r>
+            <a:r>
+              <a:rPr sz="1300" b="1" u="sng" dirty="0"/>
+              <a:t>Greedy Nearest-Neighbor Pathfinder routing:</a:t>
             </a:r>
           </a:p>
           <a:p>
@@ -8779,7 +8366,20 @@
               </a:defRPr>
             </a:pPr>
             <a:r>
-              <a:t>     - Solves Traveling Salesperson Problem (TSP) exactly to find the absolute shortest round tour.</a:t>
+              <a:rPr lang="en-US" sz="1300" dirty="0"/>
+              <a:t>    </a:t>
+            </a:r>
+            <a:r>
+              <a:rPr sz="1300" dirty="0"/>
+              <a:t> - </a:t>
+            </a:r>
+            <a:r>
+              <a:rPr lang="en-US" sz="1300" dirty="0"/>
+              <a:t>S</a:t>
+            </a:r>
+            <a:r>
+              <a:rPr sz="1300" dirty="0"/>
+              <a:t>tarts at max congestion, sequentially pathing to nearest hotspot.</a:t>
             </a:r>
           </a:p>
           <a:p>
@@ -8795,7 +8395,12 @@
               </a:defRPr>
             </a:pPr>
             <a:r>
-              <a:t>    - Snaps path to live road geometry via OSRM, including real turn-by-turn navigation.</a:t>
+              <a:rPr lang="en-US" sz="1300" dirty="0"/>
+              <a:t>    </a:t>
+            </a:r>
+            <a:r>
+              <a:rPr sz="1300" dirty="0"/>
+              <a:t>- O(N^2) complexity with local path planning executed in &lt;1ms.</a:t>
             </a:r>
           </a:p>
           <a:p>
@@ -9861,7 +9466,7 @@
               </a:defRPr>
             </a:pPr>
             <a:r>
-              <a:t>Pathfinder calculates exact TSP route snapped to road network in &lt;1ms.</a:t>
+              <a:t>Pathfinder maps optimal routes sequentially in &lt;1ms.</a:t>
             </a:r>
           </a:p>
         </p:txBody>
@@ -9906,7 +9511,6 @@
               </a:defRPr>
             </a:pPr>
             <a:r>
-              <a:rPr dirty="0"/>
               <a:t>5. Dispatch warden</a:t>
             </a:r>
           </a:p>
@@ -9920,7 +9524,7 @@
               </a:defRPr>
             </a:pPr>
             <a:r>
-              <a:t>Warden gets real-time GPS turn-by-turn navigation in the dashboard.</a:t>
+              <a:t>Officers navigate drawn polylines to clear blockages.</a:t>
             </a:r>
           </a:p>
         </p:txBody>
@@ -10388,299 +9992,4 @@
   </a:objectDefaults>
   <a:extraClrSchemeLst/>
 </a:theme>
-</file>
-
-<file path=ppt/theme/theme2.xml><?xml version="1.0" encoding="utf-8"?>
-<a:theme xmlns:a="http://schemas.openxmlformats.org/drawingml/2006/main" name="Office Theme">
-  <a:themeElements>
-    <a:clrScheme name="Office">
-      <a:dk1>
-        <a:sysClr val="windowText" lastClr="000000"/>
-      </a:dk1>
-      <a:lt1>
-        <a:sysClr val="window" lastClr="FFFFFF"/>
-      </a:lt1>
-      <a:dk2>
-        <a:srgbClr val="44546A"/>
-      </a:dk2>
-      <a:lt2>
-        <a:srgbClr val="E7E6E6"/>
-      </a:lt2>
-      <a:accent1>
-        <a:srgbClr val="4472C4"/>
-      </a:accent1>
-      <a:accent2>
-        <a:srgbClr val="ED7D31"/>
-      </a:accent2>
-      <a:accent3>
-        <a:srgbClr val="A5A5A5"/>
-      </a:accent3>
-      <a:accent4>
-        <a:srgbClr val="FFC000"/>
-      </a:accent4>
-      <a:accent5>
-        <a:srgbClr val="5B9BD5"/>
-      </a:accent5>
-      <a:accent6>
-        <a:srgbClr val="70AD47"/>
-      </a:accent6>
-      <a:hlink>
-        <a:srgbClr val="0563C1"/>
-      </a:hlink>
-      <a:folHlink>
-        <a:srgbClr val="954F72"/>
-      </a:folHlink>
-    </a:clrScheme>
-    <a:fontScheme name="Office">
-      <a:majorFont>
-        <a:latin typeface="Calibri Light" panose="020F0302020204030204"/>
-        <a:ea typeface=""/>
-        <a:cs typeface=""/>
-        <a:font script="Jpan" typeface="游ゴシック Light"/>
-        <a:font script="Hang" typeface="맑은 고딕"/>
-        <a:font script="Hans" typeface="等线 Light"/>
-        <a:font script="Hant" typeface="新細明體"/>
-        <a:font script="Arab" typeface="Times New Roman"/>
-        <a:font script="Hebr" typeface="Times New Roman"/>
-        <a:font script="Thai" typeface="Angsana New"/>
-        <a:font script="Ethi" typeface="Nyala"/>
-        <a:font script="Beng" typeface="Vrinda"/>
-        <a:font script="Gujr" typeface="Shruti"/>
-        <a:font script="Khmr" typeface="MoolBoran"/>
-        <a:font script="Knda" typeface="Tunga"/>
-        <a:font script="Guru" typeface="Raavi"/>
-        <a:font script="Cans" typeface="Euphemia"/>
-        <a:font script="Cher" typeface="Plantagenet Cherokee"/>
-        <a:font script="Yiii" typeface="Microsoft Yi Baiti"/>
-        <a:font script="Tibt" typeface="Microsoft Himalaya"/>
-        <a:font script="Thaa" typeface="MV Boli"/>
-        <a:font script="Deva" typeface="Mangal"/>
-        <a:font script="Telu" typeface="Gautami"/>
-        <a:font script="Taml" typeface="Latha"/>
-        <a:font script="Syrc" typeface="Estrangelo Edessa"/>
-        <a:font script="Orya" typeface="Kalinga"/>
-        <a:font script="Mlym" typeface="Kartika"/>
-        <a:font script="Laoo" typeface="DokChampa"/>
-        <a:font script="Sinh" typeface="Iskoola Pota"/>
-        <a:font script="Mong" typeface="Mongolian Baiti"/>
-        <a:font script="Viet" typeface="Times New Roman"/>
-        <a:font script="Uigh" typeface="Microsoft Uighur"/>
-        <a:font script="Geor" typeface="Sylfaen"/>
-        <a:font script="Armn" typeface="Arial"/>
-        <a:font script="Bugi" typeface="Leelawadee UI"/>
-        <a:font script="Bopo" typeface="Microsoft JhengHei"/>
-        <a:font script="Java" typeface="Javanese Text"/>
-        <a:font script="Lisu" typeface="Segoe UI"/>
-        <a:font script="Mymr" typeface="Myanmar Text"/>
-        <a:font script="Nkoo" typeface="Ebrima"/>
-        <a:font script="Olck" typeface="Nirmala UI"/>
-        <a:font script="Osma" typeface="Ebrima"/>
-        <a:font script="Phag" typeface="Phagspa"/>
-        <a:font script="Syrn" typeface="Estrangelo Edessa"/>
-        <a:font script="Syrj" typeface="Estrangelo Edessa"/>
-        <a:font script="Syre" typeface="Estrangelo Edessa"/>
-        <a:font script="Sora" typeface="Nirmala UI"/>
-        <a:font script="Tale" typeface="Microsoft Tai Le"/>
-        <a:font script="Talu" typeface="Microsoft New Tai Lue"/>
-        <a:font script="Tfng" typeface="Ebrima"/>
-      </a:majorFont>
-      <a:minorFont>
-        <a:latin typeface="Calibri" panose="020F0502020204030204"/>
-        <a:ea typeface=""/>
-        <a:cs typeface=""/>
-        <a:font script="Jpan" typeface="游ゴシック"/>
-        <a:font script="Hang" typeface="맑은 고딕"/>
-        <a:font script="Hans" typeface="等线"/>
-        <a:font script="Hant" typeface="新細明體"/>
-        <a:font script="Arab" typeface="Arial"/>
-        <a:font script="Hebr" typeface="Arial"/>
-        <a:font script="Thai" typeface="Cordia New"/>
-        <a:font script="Ethi" typeface="Nyala"/>
-        <a:font script="Beng" typeface="Vrinda"/>
-        <a:font script="Gujr" typeface="Shruti"/>
-        <a:font script="Khmr" typeface="DaunPenh"/>
-        <a:font script="Knda" typeface="Tunga"/>
-        <a:font script="Guru" typeface="Raavi"/>
-        <a:font script="Cans" typeface="Euphemia"/>
-        <a:font script="Cher" typeface="Plantagenet Cherokee"/>
-        <a:font script="Yiii" typeface="Microsoft Yi Baiti"/>
-        <a:font script="Tibt" typeface="Microsoft Himalaya"/>
-        <a:font script="Thaa" typeface="MV Boli"/>
-        <a:font script="Deva" typeface="Mangal"/>
-        <a:font script="Telu" typeface="Gautami"/>
-        <a:font script="Taml" typeface="Latha"/>
-        <a:font script="Syrc" typeface="Estrangelo Edessa"/>
-        <a:font script="Orya" typeface="Kalinga"/>
-        <a:font script="Mlym" typeface="Kartika"/>
-        <a:font script="Laoo" typeface="DokChampa"/>
-        <a:font script="Sinh" typeface="Iskoola Pota"/>
-        <a:font script="Mong" typeface="Mongolian Baiti"/>
-        <a:font script="Viet" typeface="Arial"/>
-        <a:font script="Uigh" typeface="Microsoft Uighur"/>
-        <a:font script="Geor" typeface="Sylfaen"/>
-        <a:font script="Armn" typeface="Arial"/>
-        <a:font script="Bugi" typeface="Leelawadee UI"/>
-        <a:font script="Bopo" typeface="Microsoft JhengHei"/>
-        <a:font script="Java" typeface="Javanese Text"/>
-        <a:font script="Lisu" typeface="Segoe UI"/>
-        <a:font script="Mymr" typeface="Myanmar Text"/>
-        <a:font script="Nkoo" typeface="Ebrima"/>
-        <a:font script="Olck" typeface="Nirmala UI"/>
-        <a:font script="Osma" typeface="Ebrima"/>
-        <a:font script="Phag" typeface="Phagspa"/>
-        <a:font script="Syrn" typeface="Estrangelo Edessa"/>
-        <a:font script="Syrj" typeface="Estrangelo Edessa"/>
-        <a:font script="Syre" typeface="Estrangelo Edessa"/>
-        <a:font script="Sora" typeface="Nirmala UI"/>
-        <a:font script="Tale" typeface="Microsoft Tai Le"/>
-        <a:font script="Talu" typeface="Microsoft New Tai Lue"/>
-        <a:font script="Tfng" typeface="Ebrima"/>
-      </a:minorFont>
-    </a:fontScheme>
-    <a:fmtScheme name="Office">
-      <a:fillStyleLst>
-        <a:solidFill>
-          <a:schemeClr val="phClr"/>
-        </a:solidFill>
-        <a:gradFill rotWithShape="1">
-          <a:gsLst>
-            <a:gs pos="0">
-              <a:schemeClr val="phClr">
-                <a:lumMod val="110000"/>
-                <a:satMod val="105000"/>
-                <a:tint val="67000"/>
-              </a:schemeClr>
-            </a:gs>
-            <a:gs pos="50000">
-              <a:schemeClr val="phClr">
-                <a:lumMod val="105000"/>
-                <a:satMod val="103000"/>
-                <a:tint val="73000"/>
-              </a:schemeClr>
-            </a:gs>
-            <a:gs pos="100000">
-              <a:schemeClr val="phClr">
-                <a:lumMod val="105000"/>
-                <a:satMod val="109000"/>
-                <a:tint val="81000"/>
-              </a:schemeClr>
-            </a:gs>
-          </a:gsLst>
-          <a:lin ang="5400000" scaled="0"/>
-        </a:gradFill>
-        <a:gradFill rotWithShape="1">
-          <a:gsLst>
-            <a:gs pos="0">
-              <a:schemeClr val="phClr">
-                <a:satMod val="103000"/>
-                <a:lumMod val="102000"/>
-                <a:tint val="94000"/>
-              </a:schemeClr>
-            </a:gs>
-            <a:gs pos="50000">
-              <a:schemeClr val="phClr">
-                <a:satMod val="110000"/>
-                <a:lumMod val="100000"/>
-                <a:shade val="100000"/>
-              </a:schemeClr>
-            </a:gs>
-            <a:gs pos="100000">
-              <a:schemeClr val="phClr">
-                <a:lumMod val="99000"/>
-                <a:satMod val="120000"/>
-                <a:shade val="78000"/>
-              </a:schemeClr>
-            </a:gs>
-          </a:gsLst>
-          <a:lin ang="5400000" scaled="0"/>
-        </a:gradFill>
-      </a:fillStyleLst>
-      <a:lnStyleLst>
-        <a:ln w="6350" cap="flat" cmpd="sng" algn="ctr">
-          <a:solidFill>
-            <a:schemeClr val="phClr"/>
-          </a:solidFill>
-          <a:prstDash val="solid"/>
-          <a:miter lim="800000"/>
-        </a:ln>
-        <a:ln w="12700" cap="flat" cmpd="sng" algn="ctr">
-          <a:solidFill>
-            <a:schemeClr val="phClr"/>
-          </a:solidFill>
-          <a:prstDash val="solid"/>
-          <a:miter lim="800000"/>
-        </a:ln>
-        <a:ln w="19050" cap="flat" cmpd="sng" algn="ctr">
-          <a:solidFill>
-            <a:schemeClr val="phClr"/>
-          </a:solidFill>
-          <a:prstDash val="solid"/>
-          <a:miter lim="800000"/>
-        </a:ln>
-      </a:lnStyleLst>
-      <a:effectStyleLst>
-        <a:effectStyle>
-          <a:effectLst/>
-        </a:effectStyle>
-        <a:effectStyle>
-          <a:effectLst/>
-        </a:effectStyle>
-        <a:effectStyle>
-          <a:effectLst>
-            <a:outerShdw blurRad="57150" dist="19050" dir="5400000" algn="ctr" rotWithShape="0">
-              <a:srgbClr val="000000">
-                <a:alpha val="63000"/>
-              </a:srgbClr>
-            </a:outerShdw>
-          </a:effectLst>
-        </a:effectStyle>
-      </a:effectStyleLst>
-      <a:bgFillStyleLst>
-        <a:solidFill>
-          <a:schemeClr val="phClr"/>
-        </a:solidFill>
-        <a:solidFill>
-          <a:schemeClr val="phClr">
-            <a:tint val="95000"/>
-            <a:satMod val="170000"/>
-          </a:schemeClr>
-        </a:solidFill>
-        <a:gradFill rotWithShape="1">
-          <a:gsLst>
-            <a:gs pos="0">
-              <a:schemeClr val="phClr">
-                <a:tint val="93000"/>
-                <a:satMod val="150000"/>
-                <a:shade val="98000"/>
-                <a:lumMod val="102000"/>
-              </a:schemeClr>
-            </a:gs>
-            <a:gs pos="50000">
-              <a:schemeClr val="phClr">
-                <a:tint val="98000"/>
-                <a:satMod val="130000"/>
-                <a:shade val="90000"/>
-                <a:lumMod val="103000"/>
-              </a:schemeClr>
-            </a:gs>
-            <a:gs pos="100000">
-              <a:schemeClr val="phClr">
-                <a:shade val="63000"/>
-                <a:satMod val="120000"/>
-              </a:schemeClr>
-            </a:gs>
-          </a:gsLst>
-          <a:lin ang="5400000" scaled="0"/>
-        </a:gradFill>
-      </a:bgFillStyleLst>
-    </a:fmtScheme>
-  </a:themeElements>
-  <a:objectDefaults/>
-  <a:extraClrSchemeLst/>
-  <a:extLst>
-    <a:ext uri="{05A4C25C-085E-4340-85A3-A5531E510DB2}">
-      <thm15:themeFamily xmlns:thm15="http://schemas.microsoft.com/office/thememl/2012/main" name="Office Theme" id="{62F939B6-93AF-4DB8-9C6B-D6C7DFDC589F}" vid="{4A3C46E8-61CC-4603-A589-7422A47A8E4A}"/>
-    </a:ext>
-  </a:extLst>
-</a:theme>
 </file>
</xml_diff>

<commit_message>
Update presentation text for exact TSP and snapped routing while preserving original formatting
</commit_message>
<xml_diff>
--- a/Flikart_Grid_Lock_hackathon_Round_2_Confluent.pptx
+++ b/Flikart_Grid_Lock_hackathon_Round_2_Confluent.pptx
@@ -3213,7 +3213,7 @@
 </file>
 
 <file path=ppt/slides/slide10.xml><?xml version="1.0" encoding="utf-8"?>
-<p:sld xmlns:a="http://schemas.openxmlformats.org/drawingml/2006/main" xmlns:r="http://schemas.openxmlformats.org/officeDocument/2006/relationships" xmlns:p="http://schemas.openxmlformats.org/presentationml/2006/main">
+<p:sld xmlns:a="http://schemas.openxmlformats.org/drawingml/2006/main" xmlns:ns2="http://schemas.microsoft.com/office/drawing/2014/main" xmlns:ns4="http://schemas.microsoft.com/office/powerpoint/2010/main" xmlns:p="http://schemas.openxmlformats.org/presentationml/2006/main" xmlns:r="http://schemas.openxmlformats.org/officeDocument/2006/relationships">
   <p:cSld>
     <p:spTree>
       <p:nvGrpSpPr>
@@ -3234,7 +3234,7 @@
           <p:cNvPr id="2" name="Picture 1">
             <a:extLst>
               <a:ext uri="{FF2B5EF4-FFF2-40B4-BE49-F238E27FC236}">
-                <a16:creationId xmlns:a16="http://schemas.microsoft.com/office/drawing/2014/main" id="{143FD7A8-E874-004E-904B-41DB4376F8FF}"/>
+                <ns2:creationId id="{143FD7A8-E874-004E-904B-41DB4376F8FF}"/>
               </a:ext>
             </a:extLst>
           </p:cNvPr>
@@ -3264,7 +3264,7 @@
           <p:cNvPr id="4" name="TextBox 3">
             <a:extLst>
               <a:ext uri="{FF2B5EF4-FFF2-40B4-BE49-F238E27FC236}">
-                <a16:creationId xmlns:a16="http://schemas.microsoft.com/office/drawing/2014/main" id="{C9A255F7-5B9A-BD4B-94BB-CCD7448F7F99}"/>
+                <ns2:creationId id="{C9A255F7-5B9A-BD4B-94BB-CCD7448F7F99}"/>
               </a:ext>
             </a:extLst>
           </p:cNvPr>
@@ -3311,7 +3311,7 @@
           <p:cNvPr id="5" name="Rectangle 4">
             <a:extLst>
               <a:ext uri="{FF2B5EF4-FFF2-40B4-BE49-F238E27FC236}">
-                <a16:creationId xmlns:a16="http://schemas.microsoft.com/office/drawing/2014/main" id="{BA2A47BC-6C1C-4E49-A600-A1F67824753F}"/>
+                <ns2:creationId id="{BA2A47BC-6C1C-4E49-A600-A1F67824753F}"/>
               </a:ext>
             </a:extLst>
           </p:cNvPr>
@@ -3363,7 +3363,7 @@
           <p:cNvPr id="6" name="Rectangle 5">
             <a:extLst>
               <a:ext uri="{FF2B5EF4-FFF2-40B4-BE49-F238E27FC236}">
-                <a16:creationId xmlns:a16="http://schemas.microsoft.com/office/drawing/2014/main" id="{A82FBD0E-4877-2F48-A230-1AE868A731A2}"/>
+                <ns2:creationId id="{A82FBD0E-4877-2F48-A230-1AE868A731A2}"/>
               </a:ext>
             </a:extLst>
           </p:cNvPr>
@@ -3415,7 +3415,7 @@
           <p:cNvPr id="7" name="TextBox 6">
             <a:extLst>
               <a:ext uri="{FF2B5EF4-FFF2-40B4-BE49-F238E27FC236}">
-                <a16:creationId xmlns:a16="http://schemas.microsoft.com/office/drawing/2014/main" id="{57CBAB3A-1420-4246-BA59-E78D748AEB37}"/>
+                <ns2:creationId id="{57CBAB3A-1420-4246-BA59-E78D748AEB37}"/>
               </a:ext>
             </a:extLst>
           </p:cNvPr>
@@ -3536,7 +3536,7 @@
           <p:cNvPr id="8" name="TextBox 7">
             <a:extLst>
               <a:ext uri="{FF2B5EF4-FFF2-40B4-BE49-F238E27FC236}">
-                <a16:creationId xmlns:a16="http://schemas.microsoft.com/office/drawing/2014/main" id="{3B43FCF8-7ECA-3A45-935D-E288116CE0F4}"/>
+                <ns2:creationId id="{3B43FCF8-7ECA-3A45-935D-E288116CE0F4}"/>
               </a:ext>
             </a:extLst>
           </p:cNvPr>
@@ -3690,7 +3690,7 @@
             </a:pPr>
             <a:r>
               <a:rPr lang="en-US" sz="1400" dirty="0"/>
-              <a:t>      - Warden navigation app. Deploy towing fleet size matching.</a:t>
+              <a:t>      - Live turn-by-turn mobile app sync. Deploy towing fleet size matching.</a:t>
             </a:r>
           </a:p>
           <a:p>
@@ -3802,7 +3802,7 @@
     </p:spTree>
     <p:extLst>
       <p:ext uri="{BB962C8B-B14F-4D97-AF65-F5344CB8AC3E}">
-        <p14:creationId xmlns:p14="http://schemas.microsoft.com/office/powerpoint/2010/main" val="53895298"/>
+        <ns4:creationId val="53895298"/>
       </p:ext>
     </p:extLst>
   </p:cSld>
@@ -5376,7 +5376,7 @@
 </file>
 
 <file path=ppt/slides/slide3.xml><?xml version="1.0" encoding="utf-8"?>
-<p:sld xmlns:a="http://schemas.openxmlformats.org/drawingml/2006/main" xmlns:r="http://schemas.openxmlformats.org/officeDocument/2006/relationships" xmlns:p="http://schemas.openxmlformats.org/presentationml/2006/main">
+<p:sld xmlns:a="http://schemas.openxmlformats.org/drawingml/2006/main" xmlns:ns2="http://schemas.microsoft.com/office/drawing/2014/main" xmlns:p="http://schemas.openxmlformats.org/presentationml/2006/main" xmlns:r="http://schemas.openxmlformats.org/officeDocument/2006/relationships">
   <p:cSld>
     <p:spTree>
       <p:nvGrpSpPr>
@@ -5397,7 +5397,7 @@
           <p:cNvPr id="9" name="Picture 8">
             <a:extLst>
               <a:ext uri="{FF2B5EF4-FFF2-40B4-BE49-F238E27FC236}">
-                <a16:creationId xmlns:a16="http://schemas.microsoft.com/office/drawing/2014/main" id="{7A42C098-EAAE-EB43-953A-7E6C49B5659C}"/>
+                <ns2:creationId id="{7A42C098-EAAE-EB43-953A-7E6C49B5659C}"/>
               </a:ext>
             </a:extLst>
           </p:cNvPr>
@@ -5427,7 +5427,7 @@
           <p:cNvPr id="10" name="TextBox 9">
             <a:extLst>
               <a:ext uri="{FF2B5EF4-FFF2-40B4-BE49-F238E27FC236}">
-                <a16:creationId xmlns:a16="http://schemas.microsoft.com/office/drawing/2014/main" id="{23EDEF7D-EB50-3F44-B1BF-97387FC6B236}"/>
+                <ns2:creationId id="{23EDEF7D-EB50-3F44-B1BF-97387FC6B236}"/>
               </a:ext>
             </a:extLst>
           </p:cNvPr>
@@ -5490,7 +5490,7 @@
           <p:cNvPr id="11" name="Rectangle 10">
             <a:extLst>
               <a:ext uri="{FF2B5EF4-FFF2-40B4-BE49-F238E27FC236}">
-                <a16:creationId xmlns:a16="http://schemas.microsoft.com/office/drawing/2014/main" id="{D60F235F-72C2-A841-B4EA-6F41F9E586D8}"/>
+                <ns2:creationId id="{D60F235F-72C2-A841-B4EA-6F41F9E586D8}"/>
               </a:ext>
             </a:extLst>
           </p:cNvPr>
@@ -5542,7 +5542,7 @@
           <p:cNvPr id="12" name="Rectangle 11">
             <a:extLst>
               <a:ext uri="{FF2B5EF4-FFF2-40B4-BE49-F238E27FC236}">
-                <a16:creationId xmlns:a16="http://schemas.microsoft.com/office/drawing/2014/main" id="{F8B63641-7DC0-3743-87C7-B806CB7E3A52}"/>
+                <ns2:creationId id="{F8B63641-7DC0-3743-87C7-B806CB7E3A52}"/>
               </a:ext>
             </a:extLst>
           </p:cNvPr>
@@ -5594,7 +5594,7 @@
           <p:cNvPr id="13" name="TextBox 12">
             <a:extLst>
               <a:ext uri="{FF2B5EF4-FFF2-40B4-BE49-F238E27FC236}">
-                <a16:creationId xmlns:a16="http://schemas.microsoft.com/office/drawing/2014/main" id="{ECCD5148-D21D-394E-BA04-483703BE3A88}"/>
+                <ns2:creationId id="{ECCD5148-D21D-394E-BA04-483703BE3A88}"/>
               </a:ext>
             </a:extLst>
           </p:cNvPr>
@@ -5724,7 +5724,7 @@
           <p:cNvPr id="14" name="TextBox 13">
             <a:extLst>
               <a:ext uri="{FF2B5EF4-FFF2-40B4-BE49-F238E27FC236}">
-                <a16:creationId xmlns:a16="http://schemas.microsoft.com/office/drawing/2014/main" id="{EA6BE09B-FBBC-BC46-B7DC-EDE0CC3AE7DA}"/>
+                <ns2:creationId id="{EA6BE09B-FBBC-BC46-B7DC-EDE0CC3AE7DA}"/>
               </a:ext>
             </a:extLst>
           </p:cNvPr>
@@ -5827,11 +5827,11 @@
             </a:pPr>
             <a:r>
               <a:rPr sz="1600" b="1" u="sng" dirty="0"/>
-              <a:t>• AI Patrol Route Pathfinder: </a:t>
+              <a:t>• AI Patrol Route Pathfinder: Generates exact TSP shortest tours snapped to road networks in &lt;1ms, with live GPS turn-by-turn navigation.</a:t>
             </a:r>
             <a:r>
               <a:rPr sz="1600" dirty="0"/>
-              <a:t>Generates optimized nearest-neighbor officer routing paths on the map in &lt;1ms.</a:t>
+              <a:t/>
             </a:r>
           </a:p>
           <a:p>
@@ -6799,7 +6799,7 @@
 </file>
 
 <file path=ppt/slides/slide6.xml><?xml version="1.0" encoding="utf-8"?>
-<p:sld xmlns:a="http://schemas.openxmlformats.org/drawingml/2006/main" xmlns:r="http://schemas.openxmlformats.org/officeDocument/2006/relationships" xmlns:p="http://schemas.openxmlformats.org/presentationml/2006/main">
+<p:sld xmlns:a="http://schemas.openxmlformats.org/drawingml/2006/main" xmlns:ns2="http://schemas.microsoft.com/office/drawing/2014/main" xmlns:ns4="http://schemas.microsoft.com/office/powerpoint/2010/main" xmlns:p="http://schemas.openxmlformats.org/presentationml/2006/main" xmlns:r="http://schemas.openxmlformats.org/officeDocument/2006/relationships">
   <p:cSld>
     <p:spTree>
       <p:nvGrpSpPr>
@@ -6820,7 +6820,7 @@
           <p:cNvPr id="2" name="Picture 1">
             <a:extLst>
               <a:ext uri="{FF2B5EF4-FFF2-40B4-BE49-F238E27FC236}">
-                <a16:creationId xmlns:a16="http://schemas.microsoft.com/office/drawing/2014/main" id="{8BE8E9B1-8B03-AD44-BFC1-D5406B141932}"/>
+                <ns2:creationId id="{8BE8E9B1-8B03-AD44-BFC1-D5406B141932}"/>
               </a:ext>
             </a:extLst>
           </p:cNvPr>
@@ -6850,7 +6850,7 @@
           <p:cNvPr id="4" name="TextBox 3">
             <a:extLst>
               <a:ext uri="{FF2B5EF4-FFF2-40B4-BE49-F238E27FC236}">
-                <a16:creationId xmlns:a16="http://schemas.microsoft.com/office/drawing/2014/main" id="{4E341510-B9D7-8E42-B211-C1939EDAD47C}"/>
+                <ns2:creationId id="{4E341510-B9D7-8E42-B211-C1939EDAD47C}"/>
               </a:ext>
             </a:extLst>
           </p:cNvPr>
@@ -6897,7 +6897,7 @@
           <p:cNvPr id="5" name="Rectangle 4">
             <a:extLst>
               <a:ext uri="{FF2B5EF4-FFF2-40B4-BE49-F238E27FC236}">
-                <a16:creationId xmlns:a16="http://schemas.microsoft.com/office/drawing/2014/main" id="{5722EA8D-A95A-1346-B126-B636CE4125F9}"/>
+                <ns2:creationId id="{5722EA8D-A95A-1346-B126-B636CE4125F9}"/>
               </a:ext>
             </a:extLst>
           </p:cNvPr>
@@ -6949,7 +6949,7 @@
           <p:cNvPr id="6" name="Rectangle 5">
             <a:extLst>
               <a:ext uri="{FF2B5EF4-FFF2-40B4-BE49-F238E27FC236}">
-                <a16:creationId xmlns:a16="http://schemas.microsoft.com/office/drawing/2014/main" id="{5C40FEE7-E63F-624F-BB98-A5EEE3B87F65}"/>
+                <ns2:creationId id="{5C40FEE7-E63F-624F-BB98-A5EEE3B87F65}"/>
               </a:ext>
             </a:extLst>
           </p:cNvPr>
@@ -7001,7 +7001,7 @@
           <p:cNvPr id="7" name="TextBox 6">
             <a:extLst>
               <a:ext uri="{FF2B5EF4-FFF2-40B4-BE49-F238E27FC236}">
-                <a16:creationId xmlns:a16="http://schemas.microsoft.com/office/drawing/2014/main" id="{8D4233E7-098F-094A-B255-1F63081EE261}"/>
+                <ns2:creationId id="{8D4233E7-098F-094A-B255-1F63081EE261}"/>
               </a:ext>
             </a:extLst>
           </p:cNvPr>
@@ -7122,7 +7122,7 @@
           <p:cNvPr id="8" name="TextBox 7">
             <a:extLst>
               <a:ext uri="{FF2B5EF4-FFF2-40B4-BE49-F238E27FC236}">
-                <a16:creationId xmlns:a16="http://schemas.microsoft.com/office/drawing/2014/main" id="{0B12979C-DC52-D549-A46C-FC7991E4C274}"/>
+                <ns2:creationId id="{0B12979C-DC52-D549-A46C-FC7991E4C274}"/>
               </a:ext>
             </a:extLst>
           </p:cNvPr>
@@ -7291,19 +7291,19 @@
             </a:pPr>
             <a:r>
               <a:rPr sz="1600" dirty="0"/>
-              <a:t>• </a:t>
+              <a:t>• Phase 3: Exact TSP &amp; Road-Snapping Dispatch	</a:t>
             </a:r>
             <a:r>
               <a:rPr sz="1600" b="1" u="sng" dirty="0"/>
-              <a:t>Phase 3: </a:t>
+              <a:t/>
             </a:r>
             <a:r>
               <a:rPr sz="1600" dirty="0"/>
-              <a:t>Greedy Pathfinder Dispatch</a:t>
+              <a:t/>
             </a:r>
             <a:r>
               <a:rPr lang="en-US" sz="1600" dirty="0"/>
-              <a:t>	</a:t>
+              <a:t/>
             </a:r>
           </a:p>
           <a:p>
@@ -7320,19 +7320,19 @@
             </a:pPr>
             <a:r>
               <a:rPr lang="en-US" sz="1600" dirty="0"/>
-              <a:t>	</a:t>
+              <a:t>	- Solves Exact TSP tour in &lt;1ms, snaps routes to roads using OSRM, and generates GPS turn-by-turn navigation for wardens.</a:t>
             </a:r>
             <a:r>
               <a:rPr sz="1600" dirty="0"/>
-              <a:t>- Executes nearest-neighbor routing algorithms in </a:t>
+              <a:t/>
             </a:r>
             <a:r>
               <a:rPr lang="en-US" sz="1600" dirty="0"/>
-              <a:t>	</a:t>
+              <a:t/>
             </a:r>
             <a:r>
               <a:rPr sz="1600" dirty="0"/>
-              <a:t>&lt;1ms to dispatch wardens.</a:t>
+              <a:t/>
             </a:r>
           </a:p>
         </p:txBody>
@@ -7340,7 +7340,7 @@
     </p:spTree>
     <p:extLst>
       <p:ext uri="{BB962C8B-B14F-4D97-AF65-F5344CB8AC3E}">
-        <p14:creationId xmlns:p14="http://schemas.microsoft.com/office/powerpoint/2010/main" val="2520346566"/>
+        <ns4:creationId val="2520346566"/>
       </p:ext>
     </p:extLst>
   </p:cSld>
@@ -7351,7 +7351,7 @@
 </file>
 
 <file path=ppt/slides/slide7.xml><?xml version="1.0" encoding="utf-8"?>
-<p:sld xmlns:a="http://schemas.openxmlformats.org/drawingml/2006/main" xmlns:r="http://schemas.openxmlformats.org/officeDocument/2006/relationships" xmlns:p="http://schemas.openxmlformats.org/presentationml/2006/main">
+<p:sld xmlns:a="http://schemas.openxmlformats.org/drawingml/2006/main" xmlns:ns2="http://schemas.microsoft.com/office/drawing/2014/main" xmlns:ns4="http://schemas.microsoft.com/office/powerpoint/2010/main" xmlns:p="http://schemas.openxmlformats.org/presentationml/2006/main" xmlns:r="http://schemas.openxmlformats.org/officeDocument/2006/relationships">
   <p:cSld>
     <p:spTree>
       <p:nvGrpSpPr>
@@ -7372,7 +7372,7 @@
           <p:cNvPr id="2" name="Picture 1">
             <a:extLst>
               <a:ext uri="{FF2B5EF4-FFF2-40B4-BE49-F238E27FC236}">
-                <a16:creationId xmlns:a16="http://schemas.microsoft.com/office/drawing/2014/main" id="{1CF02612-7981-E44C-ADAF-A84A83BA8E72}"/>
+                <ns2:creationId id="{1CF02612-7981-E44C-ADAF-A84A83BA8E72}"/>
               </a:ext>
             </a:extLst>
           </p:cNvPr>
@@ -7402,7 +7402,7 @@
           <p:cNvPr id="3" name="TextBox 2">
             <a:extLst>
               <a:ext uri="{FF2B5EF4-FFF2-40B4-BE49-F238E27FC236}">
-                <a16:creationId xmlns:a16="http://schemas.microsoft.com/office/drawing/2014/main" id="{7F60D933-55D6-F645-B564-739A387D5FC5}"/>
+                <ns2:creationId id="{7F60D933-55D6-F645-B564-739A387D5FC5}"/>
               </a:ext>
             </a:extLst>
           </p:cNvPr>
@@ -7449,7 +7449,7 @@
           <p:cNvPr id="4" name="Table 3">
             <a:extLst>
               <a:ext uri="{FF2B5EF4-FFF2-40B4-BE49-F238E27FC236}">
-                <a16:creationId xmlns:a16="http://schemas.microsoft.com/office/drawing/2014/main" id="{EDBE30C8-C7DA-3E47-BDB5-1BD7DA25DC23}"/>
+                <ns2:creationId id="{EDBE30C8-C7DA-3E47-BDB5-1BD7DA25DC23}"/>
               </a:ext>
             </a:extLst>
           </p:cNvPr>
@@ -7459,7 +7459,7 @@
           <p:nvPr>
             <p:extLst>
               <p:ext uri="{D42A27DB-BD31-4B8C-83A1-F6EECF244321}">
-                <p14:modId xmlns:p14="http://schemas.microsoft.com/office/powerpoint/2010/main" val="463449312"/>
+                <ns4:modId val="463449312"/>
               </p:ext>
             </p:extLst>
           </p:nvPr>
@@ -7478,21 +7478,21 @@
                 <a:gridCol w="1828800">
                   <a:extLst>
                     <a:ext uri="{9D8B030D-6E8A-4147-A177-3AD203B41FA5}">
-                      <a16:colId xmlns:a16="http://schemas.microsoft.com/office/drawing/2014/main" val="20000"/>
+                      <ns2:colId val="20000"/>
                     </a:ext>
                   </a:extLst>
                 </a:gridCol>
                 <a:gridCol w="3657600">
                   <a:extLst>
                     <a:ext uri="{9D8B030D-6E8A-4147-A177-3AD203B41FA5}">
-                      <a16:colId xmlns:a16="http://schemas.microsoft.com/office/drawing/2014/main" val="20001"/>
+                      <ns2:colId val="20001"/>
                     </a:ext>
                   </a:extLst>
                 </a:gridCol>
                 <a:gridCol w="4873752">
                   <a:extLst>
                     <a:ext uri="{9D8B030D-6E8A-4147-A177-3AD203B41FA5}">
-                      <a16:colId xmlns:a16="http://schemas.microsoft.com/office/drawing/2014/main" val="20002"/>
+                      <ns2:colId val="20002"/>
                     </a:ext>
                   </a:extLst>
                 </a:gridCol>
@@ -7573,7 +7573,7 @@
                 </a:tc>
                 <a:extLst>
                   <a:ext uri="{0D108BD9-81ED-4DB2-BD59-A6C34878D82A}">
-                    <a16:rowId xmlns:a16="http://schemas.microsoft.com/office/drawing/2014/main" val="10000"/>
+                    <ns2:rowId val="10000"/>
                   </a:ext>
                 </a:extLst>
               </a:tr>
@@ -7650,7 +7650,7 @@
                         </a:defRPr>
                       </a:pPr>
                       <a:r>
-                        <a:t>Provides a fast, component-based mapping UI with custom Leaflet markers, polyline routes, and slider panels.</a:t>
+                        <a:t>Provides a fast, component-based mapping UI with custom Leaflet markers, snapped routes, and a live GPS turn-by-turn navigation panel.</a:t>
                       </a:r>
                     </a:p>
                   </a:txBody>
@@ -7662,7 +7662,7 @@
                 </a:tc>
                 <a:extLst>
                   <a:ext uri="{0D108BD9-81ED-4DB2-BD59-A6C34878D82A}">
-                    <a16:rowId xmlns:a16="http://schemas.microsoft.com/office/drawing/2014/main" val="10001"/>
+                    <ns2:rowId val="10001"/>
                   </a:ext>
                 </a:extLst>
               </a:tr>
@@ -7742,7 +7742,7 @@
                 </a:tc>
                 <a:extLst>
                   <a:ext uri="{0D108BD9-81ED-4DB2-BD59-A6C34878D82A}">
-                    <a16:rowId xmlns:a16="http://schemas.microsoft.com/office/drawing/2014/main" val="10002"/>
+                    <ns2:rowId val="10002"/>
                   </a:ext>
                 </a:extLst>
               </a:tr>
@@ -7823,7 +7823,7 @@
                 </a:tc>
                 <a:extLst>
                   <a:ext uri="{0D108BD9-81ED-4DB2-BD59-A6C34878D82A}">
-                    <a16:rowId xmlns:a16="http://schemas.microsoft.com/office/drawing/2014/main" val="10003"/>
+                    <ns2:rowId val="10003"/>
                   </a:ext>
                 </a:extLst>
               </a:tr>
@@ -7911,7 +7911,7 @@
                 </a:tc>
                 <a:extLst>
                   <a:ext uri="{0D108BD9-81ED-4DB2-BD59-A6C34878D82A}">
-                    <a16:rowId xmlns:a16="http://schemas.microsoft.com/office/drawing/2014/main" val="10004"/>
+                    <ns2:rowId val="10004"/>
                   </a:ext>
                 </a:extLst>
               </a:tr>
@@ -7922,7 +7922,7 @@
     </p:spTree>
     <p:extLst>
       <p:ext uri="{BB962C8B-B14F-4D97-AF65-F5344CB8AC3E}">
-        <p14:creationId xmlns:p14="http://schemas.microsoft.com/office/powerpoint/2010/main" val="2430428353"/>
+        <ns4:creationId val="2430428353"/>
       </p:ext>
     </p:extLst>
   </p:cSld>
@@ -7933,7 +7933,7 @@
 </file>
 
 <file path=ppt/slides/slide8.xml><?xml version="1.0" encoding="utf-8"?>
-<p:sld xmlns:a="http://schemas.openxmlformats.org/drawingml/2006/main" xmlns:r="http://schemas.openxmlformats.org/officeDocument/2006/relationships" xmlns:p="http://schemas.openxmlformats.org/presentationml/2006/main">
+<p:sld xmlns:a="http://schemas.openxmlformats.org/drawingml/2006/main" xmlns:ns2="http://schemas.microsoft.com/office/drawing/2014/main" xmlns:ns4="http://schemas.microsoft.com/office/powerpoint/2010/main" xmlns:p="http://schemas.openxmlformats.org/presentationml/2006/main" xmlns:r="http://schemas.openxmlformats.org/officeDocument/2006/relationships">
   <p:cSld>
     <p:spTree>
       <p:nvGrpSpPr>
@@ -7954,7 +7954,7 @@
           <p:cNvPr id="2" name="Picture 1">
             <a:extLst>
               <a:ext uri="{FF2B5EF4-FFF2-40B4-BE49-F238E27FC236}">
-                <a16:creationId xmlns:a16="http://schemas.microsoft.com/office/drawing/2014/main" id="{098679DC-411A-AA49-8650-37EE5A349B4E}"/>
+                <ns2:creationId id="{098679DC-411A-AA49-8650-37EE5A349B4E}"/>
               </a:ext>
             </a:extLst>
           </p:cNvPr>
@@ -7984,7 +7984,7 @@
           <p:cNvPr id="3" name="TextBox 2">
             <a:extLst>
               <a:ext uri="{FF2B5EF4-FFF2-40B4-BE49-F238E27FC236}">
-                <a16:creationId xmlns:a16="http://schemas.microsoft.com/office/drawing/2014/main" id="{986F00C3-D3F6-AD41-955B-3B0928D273C2}"/>
+                <ns2:creationId id="{986F00C3-D3F6-AD41-955B-3B0928D273C2}"/>
               </a:ext>
             </a:extLst>
           </p:cNvPr>
@@ -8031,7 +8031,7 @@
           <p:cNvPr id="4" name="Rectangle 3">
             <a:extLst>
               <a:ext uri="{FF2B5EF4-FFF2-40B4-BE49-F238E27FC236}">
-                <a16:creationId xmlns:a16="http://schemas.microsoft.com/office/drawing/2014/main" id="{A7E23CAB-E1F2-1B4C-9D00-C99F5EF7D05D}"/>
+                <ns2:creationId id="{A7E23CAB-E1F2-1B4C-9D00-C99F5EF7D05D}"/>
               </a:ext>
             </a:extLst>
           </p:cNvPr>
@@ -8083,7 +8083,7 @@
           <p:cNvPr id="5" name="Rectangle 4">
             <a:extLst>
               <a:ext uri="{FF2B5EF4-FFF2-40B4-BE49-F238E27FC236}">
-                <a16:creationId xmlns:a16="http://schemas.microsoft.com/office/drawing/2014/main" id="{30752636-6A1C-004C-9726-5A74055C9574}"/>
+                <ns2:creationId id="{30752636-6A1C-004C-9726-5A74055C9574}"/>
               </a:ext>
             </a:extLst>
           </p:cNvPr>
@@ -8135,7 +8135,7 @@
           <p:cNvPr id="6" name="TextBox 5">
             <a:extLst>
               <a:ext uri="{FF2B5EF4-FFF2-40B4-BE49-F238E27FC236}">
-                <a16:creationId xmlns:a16="http://schemas.microsoft.com/office/drawing/2014/main" id="{53A772A5-3AA3-F04D-9925-CFD01A0D2987}"/>
+                <ns2:creationId id="{53A772A5-3AA3-F04D-9925-CFD01A0D2987}"/>
               </a:ext>
             </a:extLst>
           </p:cNvPr>
@@ -8346,11 +8346,11 @@
             </a:pPr>
             <a:r>
               <a:rPr sz="1300" dirty="0"/>
-              <a:t>• </a:t>
+              <a:t>• Exact TSP Shortest Tour Pathfinder (OSRM Road-Snapping):</a:t>
             </a:r>
             <a:r>
               <a:rPr sz="1300" b="1" u="sng" dirty="0"/>
-              <a:t>Greedy Nearest-Neighbor Pathfinder routing:</a:t>
+              <a:t/>
             </a:r>
           </a:p>
           <a:p>
@@ -8367,19 +8367,19 @@
             </a:pPr>
             <a:r>
               <a:rPr lang="en-US" sz="1300" dirty="0"/>
-              <a:t>    </a:t>
+              <a:t>     - Solves Traveling Salesperson Problem (TSP) exactly to find the absolute shortest round tour.</a:t>
             </a:r>
             <a:r>
               <a:rPr sz="1300" dirty="0"/>
-              <a:t> - </a:t>
+              <a:t/>
             </a:r>
             <a:r>
               <a:rPr lang="en-US" sz="1300" dirty="0"/>
-              <a:t>S</a:t>
+              <a:t/>
             </a:r>
             <a:r>
               <a:rPr sz="1300" dirty="0"/>
-              <a:t>tarts at max congestion, sequentially pathing to nearest hotspot.</a:t>
+              <a:t/>
             </a:r>
           </a:p>
           <a:p>
@@ -8396,11 +8396,11 @@
             </a:pPr>
             <a:r>
               <a:rPr lang="en-US" sz="1300" dirty="0"/>
-              <a:t>    </a:t>
+              <a:t>    - Snaps path to live road geometry via OSRM, including real turn-by-turn navigation.</a:t>
             </a:r>
             <a:r>
               <a:rPr sz="1300" dirty="0"/>
-              <a:t>- O(N^2) complexity with local path planning executed in &lt;1ms.</a:t>
+              <a:t/>
             </a:r>
           </a:p>
           <a:p>
@@ -8477,7 +8477,7 @@
           <p:cNvPr id="7" name="TextBox 6">
             <a:extLst>
               <a:ext uri="{FF2B5EF4-FFF2-40B4-BE49-F238E27FC236}">
-                <a16:creationId xmlns:a16="http://schemas.microsoft.com/office/drawing/2014/main" id="{2A1E3C1C-39D1-184D-8304-6D6DF71ACC42}"/>
+                <ns2:creationId id="{2A1E3C1C-39D1-184D-8304-6D6DF71ACC42}"/>
               </a:ext>
             </a:extLst>
           </p:cNvPr>
@@ -8624,7 +8624,7 @@
     </p:spTree>
     <p:extLst>
       <p:ext uri="{BB962C8B-B14F-4D97-AF65-F5344CB8AC3E}">
-        <p14:creationId xmlns:p14="http://schemas.microsoft.com/office/powerpoint/2010/main" val="1576932235"/>
+        <ns4:creationId val="1576932235"/>
       </p:ext>
     </p:extLst>
   </p:cSld>
@@ -8635,7 +8635,7 @@
 </file>
 
 <file path=ppt/slides/slide9.xml><?xml version="1.0" encoding="utf-8"?>
-<p:sld xmlns:a="http://schemas.openxmlformats.org/drawingml/2006/main" xmlns:r="http://schemas.openxmlformats.org/officeDocument/2006/relationships" xmlns:p="http://schemas.openxmlformats.org/presentationml/2006/main">
+<p:sld xmlns:a="http://schemas.openxmlformats.org/drawingml/2006/main" xmlns:ns2="http://schemas.microsoft.com/office/drawing/2014/main" xmlns:ns4="http://schemas.microsoft.com/office/powerpoint/2010/main" xmlns:p="http://schemas.openxmlformats.org/presentationml/2006/main" xmlns:r="http://schemas.openxmlformats.org/officeDocument/2006/relationships">
   <p:cSld>
     <p:spTree>
       <p:nvGrpSpPr>
@@ -8656,7 +8656,7 @@
           <p:cNvPr id="2" name="Picture 1">
             <a:extLst>
               <a:ext uri="{FF2B5EF4-FFF2-40B4-BE49-F238E27FC236}">
-                <a16:creationId xmlns:a16="http://schemas.microsoft.com/office/drawing/2014/main" id="{4BC9D8F7-CAB0-BC43-93B0-B6D5D7427CBD}"/>
+                <ns2:creationId id="{4BC9D8F7-CAB0-BC43-93B0-B6D5D7427CBD}"/>
               </a:ext>
             </a:extLst>
           </p:cNvPr>
@@ -8686,7 +8686,7 @@
           <p:cNvPr id="3" name="TextBox 2">
             <a:extLst>
               <a:ext uri="{FF2B5EF4-FFF2-40B4-BE49-F238E27FC236}">
-                <a16:creationId xmlns:a16="http://schemas.microsoft.com/office/drawing/2014/main" id="{80A62293-DFD4-7C4D-9B0E-6D1FB802597E}"/>
+                <ns2:creationId id="{80A62293-DFD4-7C4D-9B0E-6D1FB802597E}"/>
               </a:ext>
             </a:extLst>
           </p:cNvPr>
@@ -8746,7 +8746,7 @@
           <p:cNvPr id="4" name="Rectangle 3">
             <a:extLst>
               <a:ext uri="{FF2B5EF4-FFF2-40B4-BE49-F238E27FC236}">
-                <a16:creationId xmlns:a16="http://schemas.microsoft.com/office/drawing/2014/main" id="{AEF0A5C7-797B-3E4B-BC94-016057BABFA4}"/>
+                <ns2:creationId id="{AEF0A5C7-797B-3E4B-BC94-016057BABFA4}"/>
               </a:ext>
             </a:extLst>
           </p:cNvPr>
@@ -8798,7 +8798,7 @@
           <p:cNvPr id="5" name="TextBox 4">
             <a:extLst>
               <a:ext uri="{FF2B5EF4-FFF2-40B4-BE49-F238E27FC236}">
-                <a16:creationId xmlns:a16="http://schemas.microsoft.com/office/drawing/2014/main" id="{642E546A-29E6-F743-AAD2-480C51666532}"/>
+                <ns2:creationId id="{642E546A-29E6-F743-AAD2-480C51666532}"/>
               </a:ext>
             </a:extLst>
           </p:cNvPr>
@@ -8895,7 +8895,7 @@
           <p:cNvPr id="6" name="TextBox 5">
             <a:extLst>
               <a:ext uri="{FF2B5EF4-FFF2-40B4-BE49-F238E27FC236}">
-                <a16:creationId xmlns:a16="http://schemas.microsoft.com/office/drawing/2014/main" id="{6D6ADD6D-A458-1A4A-ACF0-13F33FFC58C2}"/>
+                <ns2:creationId id="{6D6ADD6D-A458-1A4A-ACF0-13F33FFC58C2}"/>
               </a:ext>
             </a:extLst>
           </p:cNvPr>
@@ -8938,7 +8938,7 @@
           <p:cNvPr id="7" name="Rectangle 6">
             <a:extLst>
               <a:ext uri="{FF2B5EF4-FFF2-40B4-BE49-F238E27FC236}">
-                <a16:creationId xmlns:a16="http://schemas.microsoft.com/office/drawing/2014/main" id="{ED22896D-B6F4-D64C-A102-A0714DC80036}"/>
+                <ns2:creationId id="{ED22896D-B6F4-D64C-A102-A0714DC80036}"/>
               </a:ext>
             </a:extLst>
           </p:cNvPr>
@@ -8990,7 +8990,7 @@
           <p:cNvPr id="9" name="Rectangle 8">
             <a:extLst>
               <a:ext uri="{FF2B5EF4-FFF2-40B4-BE49-F238E27FC236}">
-                <a16:creationId xmlns:a16="http://schemas.microsoft.com/office/drawing/2014/main" id="{8DEB89DB-CC6F-F447-9414-5462102FCB4A}"/>
+                <ns2:creationId id="{8DEB89DB-CC6F-F447-9414-5462102FCB4A}"/>
               </a:ext>
             </a:extLst>
           </p:cNvPr>
@@ -9042,7 +9042,7 @@
           <p:cNvPr id="10" name="Rectangle 9">
             <a:extLst>
               <a:ext uri="{FF2B5EF4-FFF2-40B4-BE49-F238E27FC236}">
-                <a16:creationId xmlns:a16="http://schemas.microsoft.com/office/drawing/2014/main" id="{854FB646-0087-CC45-8CC0-4C041C40E99C}"/>
+                <ns2:creationId id="{854FB646-0087-CC45-8CC0-4C041C40E99C}"/>
               </a:ext>
             </a:extLst>
           </p:cNvPr>
@@ -9094,7 +9094,7 @@
           <p:cNvPr id="11" name="Rectangle 10">
             <a:extLst>
               <a:ext uri="{FF2B5EF4-FFF2-40B4-BE49-F238E27FC236}">
-                <a16:creationId xmlns:a16="http://schemas.microsoft.com/office/drawing/2014/main" id="{5C353F58-5014-1E4E-A1CE-76CF525FAF5F}"/>
+                <ns2:creationId id="{5C353F58-5014-1E4E-A1CE-76CF525FAF5F}"/>
               </a:ext>
             </a:extLst>
           </p:cNvPr>
@@ -9146,7 +9146,7 @@
           <p:cNvPr id="12" name="Rectangle 11">
             <a:extLst>
               <a:ext uri="{FF2B5EF4-FFF2-40B4-BE49-F238E27FC236}">
-                <a16:creationId xmlns:a16="http://schemas.microsoft.com/office/drawing/2014/main" id="{C706B3A6-C3FD-9247-B885-CD6A8D6310F0}"/>
+                <ns2:creationId id="{C706B3A6-C3FD-9247-B885-CD6A8D6310F0}"/>
               </a:ext>
             </a:extLst>
           </p:cNvPr>
@@ -9198,7 +9198,7 @@
           <p:cNvPr id="13" name="TextBox 12">
             <a:extLst>
               <a:ext uri="{FF2B5EF4-FFF2-40B4-BE49-F238E27FC236}">
-                <a16:creationId xmlns:a16="http://schemas.microsoft.com/office/drawing/2014/main" id="{0C50B993-852E-754B-8B5B-58900DA100F5}"/>
+                <ns2:creationId id="{0C50B993-852E-754B-8B5B-58900DA100F5}"/>
               </a:ext>
             </a:extLst>
           </p:cNvPr>
@@ -9242,7 +9242,7 @@
           <p:cNvPr id="18" name="TextBox 17">
             <a:extLst>
               <a:ext uri="{FF2B5EF4-FFF2-40B4-BE49-F238E27FC236}">
-                <a16:creationId xmlns:a16="http://schemas.microsoft.com/office/drawing/2014/main" id="{BE8A623C-98E5-A74B-9379-F5FC6AF41E8C}"/>
+                <ns2:creationId id="{BE8A623C-98E5-A74B-9379-F5FC6AF41E8C}"/>
               </a:ext>
             </a:extLst>
           </p:cNvPr>
@@ -9302,7 +9302,7 @@
           <p:cNvPr id="19" name="TextBox 18">
             <a:extLst>
               <a:ext uri="{FF2B5EF4-FFF2-40B4-BE49-F238E27FC236}">
-                <a16:creationId xmlns:a16="http://schemas.microsoft.com/office/drawing/2014/main" id="{F424C5A0-E8D7-4E47-8564-872717C82FB8}"/>
+                <ns2:creationId id="{F424C5A0-E8D7-4E47-8564-872717C82FB8}"/>
               </a:ext>
             </a:extLst>
           </p:cNvPr>
@@ -9360,7 +9360,7 @@
           <p:cNvPr id="20" name="TextBox 19">
             <a:extLst>
               <a:ext uri="{FF2B5EF4-FFF2-40B4-BE49-F238E27FC236}">
-                <a16:creationId xmlns:a16="http://schemas.microsoft.com/office/drawing/2014/main" id="{C470AD05-95A2-9A4C-A0E2-F9FBA3C150CE}"/>
+                <ns2:creationId id="{C470AD05-95A2-9A4C-A0E2-F9FBA3C150CE}"/>
               </a:ext>
             </a:extLst>
           </p:cNvPr>
@@ -9418,7 +9418,7 @@
           <p:cNvPr id="21" name="TextBox 20">
             <a:extLst>
               <a:ext uri="{FF2B5EF4-FFF2-40B4-BE49-F238E27FC236}">
-                <a16:creationId xmlns:a16="http://schemas.microsoft.com/office/drawing/2014/main" id="{57F6F7EB-D6E4-444F-838E-B453E423C51A}"/>
+                <ns2:creationId id="{57F6F7EB-D6E4-444F-838E-B453E423C51A}"/>
               </a:ext>
             </a:extLst>
           </p:cNvPr>
@@ -9466,7 +9466,7 @@
               </a:defRPr>
             </a:pPr>
             <a:r>
-              <a:t>Pathfinder maps optimal routes sequentially in &lt;1ms.</a:t>
+              <a:t>Pathfinder calculates exact TSP route snapped to road network in &lt;1ms.</a:t>
             </a:r>
           </a:p>
         </p:txBody>
@@ -9476,7 +9476,7 @@
           <p:cNvPr id="22" name="TextBox 21">
             <a:extLst>
               <a:ext uri="{FF2B5EF4-FFF2-40B4-BE49-F238E27FC236}">
-                <a16:creationId xmlns:a16="http://schemas.microsoft.com/office/drawing/2014/main" id="{D938F028-FF45-EB47-9E8A-FB654395E896}"/>
+                <ns2:creationId id="{D938F028-FF45-EB47-9E8A-FB654395E896}"/>
               </a:ext>
             </a:extLst>
           </p:cNvPr>
@@ -9524,7 +9524,7 @@
               </a:defRPr>
             </a:pPr>
             <a:r>
-              <a:t>Officers navigate drawn polylines to clear blockages.</a:t>
+              <a:t>Warden gets real-time GPS turn-by-turn navigation in the dashboard.</a:t>
             </a:r>
           </a:p>
         </p:txBody>
@@ -9534,7 +9534,7 @@
           <p:cNvPr id="23" name="TextBox 22">
             <a:extLst>
               <a:ext uri="{FF2B5EF4-FFF2-40B4-BE49-F238E27FC236}">
-                <a16:creationId xmlns:a16="http://schemas.microsoft.com/office/drawing/2014/main" id="{0E9EDB52-5D16-6343-B939-441C0F732F2C}"/>
+                <ns2:creationId id="{0E9EDB52-5D16-6343-B939-441C0F732F2C}"/>
               </a:ext>
             </a:extLst>
           </p:cNvPr>
@@ -9578,7 +9578,7 @@
           <p:cNvPr id="24" name="TextBox 23">
             <a:extLst>
               <a:ext uri="{FF2B5EF4-FFF2-40B4-BE49-F238E27FC236}">
-                <a16:creationId xmlns:a16="http://schemas.microsoft.com/office/drawing/2014/main" id="{0470BC95-3DF4-8F4B-A866-A6333BD39B8C}"/>
+                <ns2:creationId id="{0470BC95-3DF4-8F4B-A866-A6333BD39B8C}"/>
               </a:ext>
             </a:extLst>
           </p:cNvPr>
@@ -9622,7 +9622,7 @@
           <p:cNvPr id="25" name="TextBox 24">
             <a:extLst>
               <a:ext uri="{FF2B5EF4-FFF2-40B4-BE49-F238E27FC236}">
-                <a16:creationId xmlns:a16="http://schemas.microsoft.com/office/drawing/2014/main" id="{3E50C696-BECD-5945-B7F8-5361D50AA68A}"/>
+                <ns2:creationId id="{3E50C696-BECD-5945-B7F8-5361D50AA68A}"/>
               </a:ext>
             </a:extLst>
           </p:cNvPr>
@@ -9664,7 +9664,7 @@
     </p:spTree>
     <p:extLst>
       <p:ext uri="{BB962C8B-B14F-4D97-AF65-F5344CB8AC3E}">
-        <p14:creationId xmlns:p14="http://schemas.microsoft.com/office/powerpoint/2010/main" val="4133498124"/>
+        <ns4:creationId val="4133498124"/>
       </p:ext>
     </p:extLst>
   </p:cSld>

</xml_diff>